<commit_message>
vault backup: 2025-10-24 20:12:37
</commit_message>
<xml_diff>
--- a/生物分离工程/第十组汇报ppt.pptx
+++ b/生物分离工程/第十组汇报ppt.pptx
@@ -647,6 +647,273 @@
     </a:lvl9pPr>
   </p:notesStyle>
 </p:notesMaster>
+</file>
+
+<file path=ppt/notesSlides/notesSlide1.xml><?xml version="1.0" encoding="utf-8"?>
+<p:notes xmlns:a="http://schemas.openxmlformats.org/drawingml/2006/main" xmlns:r="http://schemas.openxmlformats.org/officeDocument/2006/relationships" xmlns:p="http://schemas.openxmlformats.org/presentationml/2006/main">
+  <p:cSld>
+    <p:spTree>
+      <p:nvGrpSpPr>
+        <p:cNvPr id="1" name=""/>
+        <p:cNvGrpSpPr/>
+        <p:nvPr/>
+      </p:nvGrpSpPr>
+      <p:grpSpPr>
+        <a:xfrm>
+          <a:off x="0" y="0"/>
+          <a:ext cx="0" cy="0"/>
+          <a:chOff x="0" y="0"/>
+          <a:chExt cx="0" cy="0"/>
+        </a:xfrm>
+      </p:grpSpPr>
+      <p:sp>
+        <p:nvSpPr>
+          <p:cNvPr id="2" name="幻灯片图像占位符 1"/>
+          <p:cNvSpPr>
+            <a:spLocks noGrp="1" noRot="1" noChangeAspect="1"/>
+          </p:cNvSpPr>
+          <p:nvPr>
+            <p:ph type="sldImg"/>
+          </p:nvPr>
+        </p:nvSpPr>
+        <p:spPr/>
+      </p:sp>
+      <p:sp>
+        <p:nvSpPr>
+          <p:cNvPr id="3" name="备注占位符 2"/>
+          <p:cNvSpPr>
+            <a:spLocks noGrp="1"/>
+          </p:cNvSpPr>
+          <p:nvPr>
+            <p:ph type="body" idx="1"/>
+          </p:nvPr>
+        </p:nvSpPr>
+        <p:spPr/>
+        <p:txBody>
+          <a:bodyPr/>
+          <a:lstStyle/>
+          <a:p>
+            <a:r>
+              <a:rPr lang="zh-CN" altLang="en-US" dirty="0"/>
+              <a:t>老师，同学们，大家下午好。</a:t>
+            </a:r>
+          </a:p>
+          <a:p>
+            <a:r>
+              <a:rPr lang="zh-CN" altLang="en-US" dirty="0"/>
+              <a:t>我们是生物分离工程第十组，今天我们汇报的主题是“抗体药物偶联物（以下简称为</a:t>
+            </a:r>
+            <a:r>
+              <a:rPr lang="en-US" altLang="zh-CN" dirty="0"/>
+              <a:t>ADC</a:t>
+            </a:r>
+            <a:r>
+              <a:rPr lang="zh-CN" altLang="en-US" dirty="0"/>
+              <a:t>）的纯化” 。</a:t>
+            </a:r>
+            <a:endParaRPr lang="en-US" altLang="zh-CN" dirty="0"/>
+          </a:p>
+          <a:p>
+            <a:r>
+              <a:rPr lang="zh-CN" altLang="en-US" dirty="0"/>
+              <a:t>我是本次的汇报人吕启蒙，此处是我们本次汇报的工作安排</a:t>
+            </a:r>
+          </a:p>
+          <a:p>
+            <a:endParaRPr lang="zh-CN" altLang="en-US" dirty="0"/>
+          </a:p>
+        </p:txBody>
+      </p:sp>
+      <p:sp>
+        <p:nvSpPr>
+          <p:cNvPr id="4" name="灯片编号占位符 3"/>
+          <p:cNvSpPr>
+            <a:spLocks noGrp="1"/>
+          </p:cNvSpPr>
+          <p:nvPr>
+            <p:ph type="sldNum" sz="quarter" idx="5"/>
+          </p:nvPr>
+        </p:nvSpPr>
+        <p:spPr/>
+        <p:txBody>
+          <a:bodyPr/>
+          <a:lstStyle/>
+          <a:p>
+            <a:fld id="{337F53EF-5364-44E3-BFA2-84231755F7E3}" type="slidenum">
+              <a:rPr lang="zh-CN" altLang="en-US" smtClean="0"/>
+              <a:t>1</a:t>
+            </a:fld>
+            <a:endParaRPr lang="zh-CN" altLang="en-US"/>
+          </a:p>
+        </p:txBody>
+      </p:sp>
+    </p:spTree>
+    <p:extLst>
+      <p:ext uri="{BB962C8B-B14F-4D97-AF65-F5344CB8AC3E}">
+        <p14:creationId xmlns:p14="http://schemas.microsoft.com/office/powerpoint/2010/main" val="1574018352"/>
+      </p:ext>
+    </p:extLst>
+  </p:cSld>
+  <p:clrMapOvr>
+    <a:masterClrMapping/>
+  </p:clrMapOvr>
+</p:notes>
+</file>
+
+<file path=ppt/notesSlides/notesSlide2.xml><?xml version="1.0" encoding="utf-8"?>
+<p:notes xmlns:a="http://schemas.openxmlformats.org/drawingml/2006/main" xmlns:r="http://schemas.openxmlformats.org/officeDocument/2006/relationships" xmlns:p="http://schemas.openxmlformats.org/presentationml/2006/main">
+  <p:cSld>
+    <p:spTree>
+      <p:nvGrpSpPr>
+        <p:cNvPr id="1" name=""/>
+        <p:cNvGrpSpPr/>
+        <p:nvPr/>
+      </p:nvGrpSpPr>
+      <p:grpSpPr>
+        <a:xfrm>
+          <a:off x="0" y="0"/>
+          <a:ext cx="0" cy="0"/>
+          <a:chOff x="0" y="0"/>
+          <a:chExt cx="0" cy="0"/>
+        </a:xfrm>
+      </p:grpSpPr>
+      <p:sp>
+        <p:nvSpPr>
+          <p:cNvPr id="2" name="幻灯片图像占位符 1"/>
+          <p:cNvSpPr>
+            <a:spLocks noGrp="1" noRot="1" noChangeAspect="1"/>
+          </p:cNvSpPr>
+          <p:nvPr>
+            <p:ph type="sldImg"/>
+          </p:nvPr>
+        </p:nvSpPr>
+        <p:spPr/>
+      </p:sp>
+      <p:sp>
+        <p:nvSpPr>
+          <p:cNvPr id="3" name="备注占位符 2"/>
+          <p:cNvSpPr>
+            <a:spLocks noGrp="1"/>
+          </p:cNvSpPr>
+          <p:nvPr>
+            <p:ph type="body" idx="1"/>
+          </p:nvPr>
+        </p:nvSpPr>
+        <p:spPr/>
+        <p:txBody>
+          <a:bodyPr/>
+          <a:lstStyle/>
+          <a:p>
+            <a:r>
+              <a:rPr lang="zh-CN" altLang="en-US" dirty="0"/>
+              <a:t>我们的汇报将围绕这几个方面展开：</a:t>
+            </a:r>
+            <a:endParaRPr lang="en-US" altLang="zh-CN" dirty="0"/>
+          </a:p>
+          <a:p>
+            <a:pPr>
+              <a:buFont typeface="+mj-lt"/>
+              <a:buAutoNum type="arabicPeriod"/>
+            </a:pPr>
+            <a:r>
+              <a:rPr lang="zh-CN" altLang="en-US" dirty="0"/>
+              <a:t>首先，我们会介绍</a:t>
+            </a:r>
+            <a:r>
+              <a:rPr lang="en-US" altLang="zh-CN" dirty="0"/>
+              <a:t>ADC</a:t>
+            </a:r>
+            <a:r>
+              <a:rPr lang="zh-CN" altLang="en-US" dirty="0"/>
+              <a:t>的基本性质 。</a:t>
+            </a:r>
+          </a:p>
+          <a:p>
+            <a:pPr>
+              <a:buFont typeface="+mj-lt"/>
+              <a:buAutoNum type="arabicPeriod"/>
+            </a:pPr>
+            <a:r>
+              <a:rPr lang="zh-CN" altLang="en-US" dirty="0"/>
+              <a:t>其次，梳理</a:t>
+            </a:r>
+            <a:r>
+              <a:rPr lang="en-US" altLang="zh-CN" dirty="0"/>
+              <a:t>ADC</a:t>
+            </a:r>
+            <a:r>
+              <a:rPr lang="zh-CN" altLang="en-US" dirty="0"/>
+              <a:t>典型的制造工艺 。剖析我们分离所要解决的问题</a:t>
+            </a:r>
+          </a:p>
+          <a:p>
+            <a:pPr>
+              <a:buFont typeface="+mj-lt"/>
+              <a:buAutoNum type="arabicPeriod"/>
+            </a:pPr>
+            <a:r>
+              <a:rPr lang="zh-CN" altLang="en-US" dirty="0"/>
+              <a:t>接着，也是本此汇报的重点，我们会介绍目前几种关键的分离方法 。</a:t>
+            </a:r>
+          </a:p>
+          <a:p>
+            <a:pPr>
+              <a:buFont typeface="+mj-lt"/>
+              <a:buAutoNum type="arabicPeriod"/>
+            </a:pPr>
+            <a:r>
+              <a:rPr lang="zh-CN" altLang="en-US" dirty="0"/>
+              <a:t>最后，结合课程所学习内容，我们尝试提出一种基于</a:t>
+            </a:r>
+            <a:r>
+              <a:rPr lang="en-US" altLang="zh-CN" dirty="0"/>
+              <a:t>TFF</a:t>
+            </a:r>
+            <a:r>
+              <a:rPr lang="zh-CN" altLang="en-US"/>
+              <a:t>技术的优化思路。</a:t>
+            </a:r>
+            <a:endParaRPr lang="zh-CN" altLang="en-US" dirty="0"/>
+          </a:p>
+          <a:p>
+            <a:endParaRPr lang="zh-CN" altLang="en-US" dirty="0"/>
+          </a:p>
+        </p:txBody>
+      </p:sp>
+      <p:sp>
+        <p:nvSpPr>
+          <p:cNvPr id="4" name="灯片编号占位符 3"/>
+          <p:cNvSpPr>
+            <a:spLocks noGrp="1"/>
+          </p:cNvSpPr>
+          <p:nvPr>
+            <p:ph type="sldNum" sz="quarter" idx="5"/>
+          </p:nvPr>
+        </p:nvSpPr>
+        <p:spPr/>
+        <p:txBody>
+          <a:bodyPr/>
+          <a:lstStyle/>
+          <a:p>
+            <a:fld id="{337F53EF-5364-44E3-BFA2-84231755F7E3}" type="slidenum">
+              <a:rPr lang="zh-CN" altLang="en-US" smtClean="0"/>
+              <a:t>2</a:t>
+            </a:fld>
+            <a:endParaRPr lang="zh-CN" altLang="en-US"/>
+          </a:p>
+        </p:txBody>
+      </p:sp>
+    </p:spTree>
+    <p:extLst>
+      <p:ext uri="{BB962C8B-B14F-4D97-AF65-F5344CB8AC3E}">
+        <p14:creationId xmlns:p14="http://schemas.microsoft.com/office/powerpoint/2010/main" val="2574884872"/>
+      </p:ext>
+    </p:extLst>
+  </p:cSld>
+  <p:clrMapOvr>
+    <a:masterClrMapping/>
+  </p:clrMapOvr>
+</p:notes>
 </file>
 
 <file path=ppt/slideLayouts/slideLayout1.xml><?xml version="1.0" encoding="utf-8"?>
@@ -3616,7 +3883,7 @@
           <p:nvPr/>
         </p:nvPicPr>
         <p:blipFill>
-          <a:blip r:embed="rId2">
+          <a:blip r:embed="rId3">
             <a:extLst>
               <a:ext uri="{28A0092B-C50C-407E-A947-70E740481C1C}">
                 <a14:useLocalDpi xmlns:a14="http://schemas.microsoft.com/office/drawing/2010/main" val="0"/>
@@ -3790,8 +4057,8 @@
         </p:nvSpPr>
         <p:spPr>
           <a:xfrm>
-            <a:off x="4929753" y="5336813"/>
-            <a:ext cx="2332495" cy="460375"/>
+            <a:off x="3435424" y="5432466"/>
+            <a:ext cx="5321152" cy="1200329"/>
           </a:xfrm>
           <a:prstGeom prst="rect">
             <a:avLst/>
@@ -3807,7 +4074,26 @@
             <a:pPr algn="ctr"/>
             <a:r>
               <a:rPr lang="zh-CN" altLang="en-US" sz="2400" b="1" dirty="0"/>
-              <a:t>汇报人：吕启蒙</a:t>
+              <a:t>第十组</a:t>
+            </a:r>
+            <a:endParaRPr lang="en-US" altLang="zh-CN" sz="2400" b="1" dirty="0"/>
+          </a:p>
+          <a:p>
+            <a:pPr algn="ctr"/>
+            <a:r>
+              <a:rPr lang="zh-CN" altLang="en-US" sz="2400" b="1" dirty="0"/>
+              <a:t>资料汇总，汇报：吕启蒙</a:t>
+            </a:r>
+          </a:p>
+          <a:p>
+            <a:pPr algn="ctr"/>
+            <a:r>
+              <a:rPr lang="en-US" altLang="zh-CN" sz="2400" b="1" dirty="0"/>
+              <a:t>PPT</a:t>
+            </a:r>
+            <a:r>
+              <a:rPr lang="zh-CN" altLang="en-US" sz="2400" b="1" dirty="0"/>
+              <a:t>制作，答疑：马唐逸农</a:t>
             </a:r>
           </a:p>
         </p:txBody>
@@ -11271,7 +11557,7 @@
           <p:nvPr/>
         </p:nvPicPr>
         <p:blipFill>
-          <a:blip r:embed="rId18"/>
+          <a:blip r:embed="rId19"/>
           <a:stretch>
             <a:fillRect/>
           </a:stretch>

</xml_diff>

<commit_message>
vault backup: 2025-10-24 20:27:59
</commit_message>
<xml_diff>
--- a/生物分离工程/第十组汇报ppt.pptx
+++ b/生物分离工程/第十组汇报ppt.pptx
@@ -870,10 +870,9 @@
               <a:t>TFF</a:t>
             </a:r>
             <a:r>
-              <a:rPr lang="zh-CN" altLang="en-US"/>
+              <a:rPr lang="zh-CN" altLang="en-US" dirty="0"/>
               <a:t>技术的优化思路。</a:t>
             </a:r>
-            <a:endParaRPr lang="zh-CN" altLang="en-US" dirty="0"/>
           </a:p>
           <a:p>
             <a:endParaRPr lang="zh-CN" altLang="en-US" dirty="0"/>
@@ -907,6 +906,333 @@
     <p:extLst>
       <p:ext uri="{BB962C8B-B14F-4D97-AF65-F5344CB8AC3E}">
         <p14:creationId xmlns:p14="http://schemas.microsoft.com/office/powerpoint/2010/main" val="2574884872"/>
+      </p:ext>
+    </p:extLst>
+  </p:cSld>
+  <p:clrMapOvr>
+    <a:masterClrMapping/>
+  </p:clrMapOvr>
+</p:notes>
+</file>
+
+<file path=ppt/notesSlides/notesSlide3.xml><?xml version="1.0" encoding="utf-8"?>
+<p:notes xmlns:a="http://schemas.openxmlformats.org/drawingml/2006/main" xmlns:r="http://schemas.openxmlformats.org/officeDocument/2006/relationships" xmlns:p="http://schemas.openxmlformats.org/presentationml/2006/main">
+  <p:cSld>
+    <p:spTree>
+      <p:nvGrpSpPr>
+        <p:cNvPr id="1" name=""/>
+        <p:cNvGrpSpPr/>
+        <p:nvPr/>
+      </p:nvGrpSpPr>
+      <p:grpSpPr>
+        <a:xfrm>
+          <a:off x="0" y="0"/>
+          <a:ext cx="0" cy="0"/>
+          <a:chOff x="0" y="0"/>
+          <a:chExt cx="0" cy="0"/>
+        </a:xfrm>
+      </p:grpSpPr>
+      <p:sp>
+        <p:nvSpPr>
+          <p:cNvPr id="2" name="幻灯片图像占位符 1"/>
+          <p:cNvSpPr>
+            <a:spLocks noGrp="1" noRot="1" noChangeAspect="1"/>
+          </p:cNvSpPr>
+          <p:nvPr>
+            <p:ph type="sldImg"/>
+          </p:nvPr>
+        </p:nvSpPr>
+        <p:spPr/>
+      </p:sp>
+      <p:sp>
+        <p:nvSpPr>
+          <p:cNvPr id="3" name="备注占位符 2"/>
+          <p:cNvSpPr>
+            <a:spLocks noGrp="1"/>
+          </p:cNvSpPr>
+          <p:nvPr>
+            <p:ph type="body" idx="1"/>
+          </p:nvPr>
+        </p:nvSpPr>
+        <p:spPr/>
+        <p:txBody>
+          <a:bodyPr/>
+          <a:lstStyle/>
+          <a:p>
+            <a:r>
+              <a:rPr lang="zh-CN" altLang="en-US" dirty="0"/>
+              <a:t>好 首先是我们的第一部分</a:t>
+            </a:r>
+            <a:endParaRPr lang="en-US" altLang="zh-CN" dirty="0"/>
+          </a:p>
+          <a:p>
+            <a:endParaRPr lang="zh-CN" altLang="en-US" dirty="0"/>
+          </a:p>
+        </p:txBody>
+      </p:sp>
+      <p:sp>
+        <p:nvSpPr>
+          <p:cNvPr id="4" name="灯片编号占位符 3"/>
+          <p:cNvSpPr>
+            <a:spLocks noGrp="1"/>
+          </p:cNvSpPr>
+          <p:nvPr>
+            <p:ph type="sldNum" sz="quarter" idx="5"/>
+          </p:nvPr>
+        </p:nvSpPr>
+        <p:spPr/>
+        <p:txBody>
+          <a:bodyPr/>
+          <a:lstStyle/>
+          <a:p>
+            <a:fld id="{337F53EF-5364-44E3-BFA2-84231755F7E3}" type="slidenum">
+              <a:rPr lang="zh-CN" altLang="en-US" smtClean="0"/>
+              <a:t>3</a:t>
+            </a:fld>
+            <a:endParaRPr lang="zh-CN" altLang="en-US"/>
+          </a:p>
+        </p:txBody>
+      </p:sp>
+    </p:spTree>
+    <p:extLst>
+      <p:ext uri="{BB962C8B-B14F-4D97-AF65-F5344CB8AC3E}">
+        <p14:creationId xmlns:p14="http://schemas.microsoft.com/office/powerpoint/2010/main" val="304217339"/>
+      </p:ext>
+    </p:extLst>
+  </p:cSld>
+  <p:clrMapOvr>
+    <a:masterClrMapping/>
+  </p:clrMapOvr>
+</p:notes>
+</file>
+
+<file path=ppt/notesSlides/notesSlide4.xml><?xml version="1.0" encoding="utf-8"?>
+<p:notes xmlns:a="http://schemas.openxmlformats.org/drawingml/2006/main" xmlns:r="http://schemas.openxmlformats.org/officeDocument/2006/relationships" xmlns:p="http://schemas.openxmlformats.org/presentationml/2006/main">
+  <p:cSld>
+    <p:spTree>
+      <p:nvGrpSpPr>
+        <p:cNvPr id="1" name=""/>
+        <p:cNvGrpSpPr/>
+        <p:nvPr/>
+      </p:nvGrpSpPr>
+      <p:grpSpPr>
+        <a:xfrm>
+          <a:off x="0" y="0"/>
+          <a:ext cx="0" cy="0"/>
+          <a:chOff x="0" y="0"/>
+          <a:chExt cx="0" cy="0"/>
+        </a:xfrm>
+      </p:grpSpPr>
+      <p:sp>
+        <p:nvSpPr>
+          <p:cNvPr id="2" name="幻灯片图像占位符 1"/>
+          <p:cNvSpPr>
+            <a:spLocks noGrp="1" noRot="1" noChangeAspect="1"/>
+          </p:cNvSpPr>
+          <p:nvPr>
+            <p:ph type="sldImg"/>
+          </p:nvPr>
+        </p:nvSpPr>
+        <p:spPr/>
+      </p:sp>
+      <p:sp>
+        <p:nvSpPr>
+          <p:cNvPr id="3" name="备注占位符 2"/>
+          <p:cNvSpPr>
+            <a:spLocks noGrp="1"/>
+          </p:cNvSpPr>
+          <p:nvPr>
+            <p:ph type="body" idx="1"/>
+          </p:nvPr>
+        </p:nvSpPr>
+        <p:spPr/>
+        <p:txBody>
+          <a:bodyPr/>
+          <a:lstStyle/>
+          <a:p>
+            <a:r>
+              <a:rPr lang="en-US" altLang="zh-CN" dirty="0"/>
+              <a:t>ADC</a:t>
+            </a:r>
+            <a:r>
+              <a:rPr lang="zh-CN" altLang="en-US" dirty="0"/>
+              <a:t>，全称抗体偶联药物，后续读</a:t>
+            </a:r>
+            <a:r>
+              <a:rPr lang="en-US" altLang="zh-CN" dirty="0"/>
+              <a:t>ppt</a:t>
+            </a:r>
+          </a:p>
+          <a:p>
+            <a:endParaRPr lang="en-US" altLang="zh-CN" dirty="0"/>
+          </a:p>
+          <a:p>
+            <a:r>
+              <a:rPr lang="zh-CN" altLang="en-US" dirty="0"/>
+              <a:t>如图中所示，其结构上我们可以大致总结为三部分，</a:t>
+            </a:r>
+            <a:endParaRPr lang="en-US" altLang="zh-CN" dirty="0"/>
+          </a:p>
+          <a:p>
+            <a:pPr>
+              <a:buFont typeface="+mj-lt"/>
+              <a:buAutoNum type="arabicPeriod"/>
+            </a:pPr>
+            <a:r>
+              <a:rPr lang="zh-CN" altLang="en-US" b="1" dirty="0"/>
+              <a:t>抗体（</a:t>
+            </a:r>
+            <a:r>
+              <a:rPr lang="en-US" altLang="zh-CN" b="1" dirty="0" err="1"/>
+              <a:t>mAb</a:t>
+            </a:r>
+            <a:r>
+              <a:rPr lang="zh-CN" altLang="en-US" b="1" dirty="0"/>
+              <a:t>）</a:t>
+            </a:r>
+            <a:r>
+              <a:rPr lang="zh-CN" altLang="en-US" dirty="0"/>
+              <a:t>：作为“制导系统”，靶向肿瘤细胞 。</a:t>
+            </a:r>
+          </a:p>
+          <a:p>
+            <a:pPr>
+              <a:buFont typeface="+mj-lt"/>
+              <a:buAutoNum type="arabicPeriod"/>
+            </a:pPr>
+            <a:r>
+              <a:rPr lang="zh-CN" altLang="en-US" b="1" dirty="0"/>
+              <a:t>小分子细胞毒素（</a:t>
+            </a:r>
+            <a:r>
+              <a:rPr lang="en-US" altLang="zh-CN" b="1" dirty="0"/>
+              <a:t>Payload</a:t>
+            </a:r>
+            <a:r>
+              <a:rPr lang="zh-CN" altLang="en-US" b="1" dirty="0"/>
+              <a:t>）</a:t>
+            </a:r>
+            <a:r>
+              <a:rPr lang="zh-CN" altLang="en-US" dirty="0"/>
+              <a:t>：作为“弹头”，具有超高毒性 。</a:t>
+            </a:r>
+          </a:p>
+          <a:p>
+            <a:pPr>
+              <a:buFont typeface="+mj-lt"/>
+              <a:buAutoNum type="arabicPeriod"/>
+            </a:pPr>
+            <a:r>
+              <a:rPr lang="zh-CN" altLang="en-US" b="1" dirty="0"/>
+              <a:t>连接子（</a:t>
+            </a:r>
+            <a:r>
+              <a:rPr lang="en-US" altLang="zh-CN" b="1" dirty="0"/>
+              <a:t>Linker</a:t>
+            </a:r>
+            <a:r>
+              <a:rPr lang="zh-CN" altLang="en-US" b="1" dirty="0"/>
+              <a:t>）</a:t>
+            </a:r>
+            <a:r>
+              <a:rPr lang="zh-CN" altLang="en-US" dirty="0"/>
+              <a:t>：将两者连接起来，需在血浆中稳定，入胞后释放药物 。</a:t>
+            </a:r>
+          </a:p>
+          <a:p>
+            <a:pPr marL="0" marR="0" lvl="0" indent="0" algn="l" defTabSz="914400" rtl="0" eaLnBrk="1" fontAlgn="auto" latinLnBrk="0" hangingPunct="1">
+              <a:lnSpc>
+                <a:spcPct val="100000"/>
+              </a:lnSpc>
+              <a:spcBef>
+                <a:spcPts val="0"/>
+              </a:spcBef>
+              <a:spcAft>
+                <a:spcPts val="0"/>
+              </a:spcAft>
+              <a:buClrTx/>
+              <a:buSzTx/>
+              <a:buFontTx/>
+              <a:buNone/>
+              <a:tabLst/>
+              <a:defRPr/>
+            </a:pPr>
+            <a:endParaRPr lang="en-US" altLang="zh-CN" dirty="0"/>
+          </a:p>
+          <a:p>
+            <a:pPr marL="0" marR="0" lvl="0" indent="0" algn="l" defTabSz="914400" rtl="0" eaLnBrk="1" fontAlgn="auto" latinLnBrk="0" hangingPunct="1">
+              <a:lnSpc>
+                <a:spcPct val="100000"/>
+              </a:lnSpc>
+              <a:spcBef>
+                <a:spcPts val="0"/>
+              </a:spcBef>
+              <a:spcAft>
+                <a:spcPts val="0"/>
+              </a:spcAft>
+              <a:buClrTx/>
+              <a:buSzTx/>
+              <a:buFontTx/>
+              <a:buNone/>
+              <a:tabLst/>
+              <a:defRPr/>
+            </a:pPr>
+            <a:r>
+              <a:rPr lang="zh-CN" altLang="en-US" dirty="0"/>
+              <a:t>它的核心应用就是</a:t>
+            </a:r>
+            <a:r>
+              <a:rPr lang="zh-CN" altLang="en-US" b="1" dirty="0"/>
+              <a:t>肿瘤治疗</a:t>
+            </a:r>
+            <a:r>
+              <a:rPr lang="zh-CN" altLang="en-US" dirty="0"/>
+              <a:t>，作为一种靶向癌症疗法，利用抗体的特异性像“生物导弹”一样精准识别肿瘤细胞，并将高效的细胞毒素递送至其内部</a:t>
+            </a:r>
+            <a:r>
+              <a:rPr lang="zh-CN" altLang="en-US"/>
+              <a:t>进行杀伤，</a:t>
+            </a:r>
+            <a:r>
+              <a:rPr lang="zh-CN" altLang="en-US" dirty="0"/>
+              <a:t>实现对癌细胞的精准杀伤，同时降低对健康组织的副作用。</a:t>
+            </a:r>
+          </a:p>
+          <a:p>
+            <a:endParaRPr lang="en-US" altLang="zh-CN" dirty="0"/>
+          </a:p>
+          <a:p>
+            <a:endParaRPr lang="zh-CN" altLang="en-US" dirty="0"/>
+          </a:p>
+        </p:txBody>
+      </p:sp>
+      <p:sp>
+        <p:nvSpPr>
+          <p:cNvPr id="4" name="灯片编号占位符 3"/>
+          <p:cNvSpPr>
+            <a:spLocks noGrp="1"/>
+          </p:cNvSpPr>
+          <p:nvPr>
+            <p:ph type="sldNum" sz="quarter" idx="5"/>
+          </p:nvPr>
+        </p:nvSpPr>
+        <p:spPr/>
+        <p:txBody>
+          <a:bodyPr/>
+          <a:lstStyle/>
+          <a:p>
+            <a:fld id="{337F53EF-5364-44E3-BFA2-84231755F7E3}" type="slidenum">
+              <a:rPr lang="zh-CN" altLang="en-US" smtClean="0"/>
+              <a:t>4</a:t>
+            </a:fld>
+            <a:endParaRPr lang="zh-CN" altLang="en-US"/>
+          </a:p>
+        </p:txBody>
+      </p:sp>
+    </p:spTree>
+    <p:extLst>
+      <p:ext uri="{BB962C8B-B14F-4D97-AF65-F5344CB8AC3E}">
+        <p14:creationId xmlns:p14="http://schemas.microsoft.com/office/powerpoint/2010/main" val="1989410614"/>
       </p:ext>
     </p:extLst>
   </p:cSld>
@@ -15170,7 +15496,7 @@
           <p:nvPr/>
         </p:nvPicPr>
         <p:blipFill>
-          <a:blip r:embed="rId2">
+          <a:blip r:embed="rId3">
             <a:extLst>
               <a:ext uri="{28A0092B-C50C-407E-A947-70E740481C1C}">
                 <a14:useLocalDpi xmlns:a14="http://schemas.microsoft.com/office/drawing/2010/main" val="0"/>
@@ -15261,7 +15587,7 @@
         <p:spPr>
           <a:xfrm>
             <a:off x="7522845" y="1130300"/>
-            <a:ext cx="4021455" cy="5939155"/>
+            <a:ext cx="4021455" cy="4708981"/>
           </a:xfrm>
           <a:prstGeom prst="rect">
             <a:avLst/>
@@ -15279,7 +15605,7 @@
               <a:buChar char="Ø"/>
             </a:pPr>
             <a:r>
-              <a:rPr lang="en-US" altLang="zh-CN" sz="2000">
+              <a:rPr lang="en-US" altLang="zh-CN" sz="2000" dirty="0">
                 <a:latin typeface="Times New Roman" panose="02020603050405020304" pitchFamily="18" charset="0"/>
                 <a:ea typeface="宋体" panose="02010600030101010101" pitchFamily="2" charset="-122"/>
                 <a:cs typeface="Times New Roman" panose="02020603050405020304" pitchFamily="18" charset="0"/>
@@ -15287,7 +15613,7 @@
               <a:t>ADC</a:t>
             </a:r>
             <a:r>
-              <a:rPr lang="zh-CN" altLang="en-US" sz="2000">
+              <a:rPr lang="zh-CN" altLang="en-US" sz="2000" dirty="0">
                 <a:latin typeface="Times New Roman" panose="02020603050405020304" pitchFamily="18" charset="0"/>
                 <a:ea typeface="宋体" panose="02010600030101010101" pitchFamily="2" charset="-122"/>
                 <a:cs typeface="Times New Roman" panose="02020603050405020304" pitchFamily="18" charset="0"/>
@@ -15295,15 +15621,23 @@
               <a:t>（</a:t>
             </a:r>
             <a:r>
-              <a:rPr lang="en-US" altLang="zh-CN" sz="2000">
-                <a:latin typeface="Times New Roman" panose="02020603050405020304" pitchFamily="18" charset="0"/>
-                <a:ea typeface="宋体" panose="02010600030101010101" pitchFamily="2" charset="-122"/>
-                <a:cs typeface="Times New Roman" panose="02020603050405020304" pitchFamily="18" charset="0"/>
-              </a:rPr>
-              <a:t>antibody–drugconjugates</a:t>
-            </a:r>
-            <a:r>
-              <a:rPr lang="zh-CN" altLang="en-US" sz="2000">
+              <a:rPr lang="en-US" altLang="zh-CN" sz="2000" dirty="0">
+                <a:latin typeface="Times New Roman" panose="02020603050405020304" pitchFamily="18" charset="0"/>
+                <a:ea typeface="宋体" panose="02010600030101010101" pitchFamily="2" charset="-122"/>
+                <a:cs typeface="Times New Roman" panose="02020603050405020304" pitchFamily="18" charset="0"/>
+              </a:rPr>
+              <a:t>antibody–</a:t>
+            </a:r>
+            <a:r>
+              <a:rPr lang="en-US" altLang="zh-CN" sz="2000" dirty="0" err="1">
+                <a:latin typeface="Times New Roman" panose="02020603050405020304" pitchFamily="18" charset="0"/>
+                <a:ea typeface="宋体" panose="02010600030101010101" pitchFamily="2" charset="-122"/>
+                <a:cs typeface="Times New Roman" panose="02020603050405020304" pitchFamily="18" charset="0"/>
+              </a:rPr>
+              <a:t>drugconjugates</a:t>
+            </a:r>
+            <a:r>
+              <a:rPr lang="zh-CN" altLang="en-US" sz="2000" dirty="0">
                 <a:latin typeface="Times New Roman" panose="02020603050405020304" pitchFamily="18" charset="0"/>
                 <a:ea typeface="宋体" panose="02010600030101010101" pitchFamily="2" charset="-122"/>
                 <a:cs typeface="Times New Roman" panose="02020603050405020304" pitchFamily="18" charset="0"/>
@@ -15312,7 +15646,7 @@
             </a:r>
           </a:p>
           <a:p>
-            <a:endParaRPr lang="en-US" altLang="zh-CN" sz="2000">
+            <a:endParaRPr lang="en-US" altLang="zh-CN" sz="2000" dirty="0">
               <a:latin typeface="Times New Roman" panose="02020603050405020304" pitchFamily="18" charset="0"/>
               <a:ea typeface="宋体" panose="02010600030101010101" pitchFamily="2" charset="-122"/>
               <a:cs typeface="Times New Roman" panose="02020603050405020304" pitchFamily="18" charset="0"/>
@@ -15324,7 +15658,7 @@
               <a:buChar char="Ø"/>
             </a:pPr>
             <a:r>
-              <a:rPr lang="en-US" altLang="zh-CN" sz="2000">
+              <a:rPr lang="en-US" altLang="zh-CN" sz="2000" dirty="0">
                 <a:latin typeface="Times New Roman" panose="02020603050405020304" pitchFamily="18" charset="0"/>
                 <a:ea typeface="宋体" panose="02010600030101010101" pitchFamily="2" charset="-122"/>
                 <a:cs typeface="Times New Roman" panose="02020603050405020304" pitchFamily="18" charset="0"/>
@@ -15332,7 +15666,7 @@
               <a:t>ADC</a:t>
             </a:r>
             <a:r>
-              <a:rPr lang="zh-CN" altLang="en-US" sz="2000">
+              <a:rPr lang="zh-CN" altLang="en-US" sz="2000" dirty="0">
                 <a:latin typeface="Times New Roman" panose="02020603050405020304" pitchFamily="18" charset="0"/>
                 <a:ea typeface="宋体" panose="02010600030101010101" pitchFamily="2" charset="-122"/>
                 <a:cs typeface="Times New Roman" panose="02020603050405020304" pitchFamily="18" charset="0"/>
@@ -15340,7 +15674,7 @@
               <a:t>的结构可分为五个部分：</a:t>
             </a:r>
             <a:r>
-              <a:rPr lang="en-US" altLang="zh-CN" sz="2000">
+              <a:rPr lang="en-US" altLang="zh-CN" sz="2000" dirty="0" err="1">
                 <a:latin typeface="Times New Roman" panose="02020603050405020304" pitchFamily="18" charset="0"/>
                 <a:ea typeface="宋体" panose="02010600030101010101" pitchFamily="2" charset="-122"/>
                 <a:cs typeface="Times New Roman" panose="02020603050405020304" pitchFamily="18" charset="0"/>
@@ -15348,7 +15682,7 @@
               <a:t>mAb</a:t>
             </a:r>
             <a:r>
-              <a:rPr lang="zh-CN" altLang="en-US" sz="2000">
+              <a:rPr lang="zh-CN" altLang="en-US" sz="2000" dirty="0">
                 <a:latin typeface="Times New Roman" panose="02020603050405020304" pitchFamily="18" charset="0"/>
                 <a:ea typeface="宋体" panose="02010600030101010101" pitchFamily="2" charset="-122"/>
                 <a:cs typeface="Times New Roman" panose="02020603050405020304" pitchFamily="18" charset="0"/>
@@ -15361,77 +15695,90 @@
               <a:buFont typeface="Wingdings" panose="05000000000000000000" charset="0"/>
               <a:buChar char="Ø"/>
             </a:pPr>
-            <a:endParaRPr lang="zh-CN" altLang="en-US" sz="2000">
+            <a:endParaRPr lang="zh-CN" altLang="en-US" sz="2000" dirty="0">
               <a:latin typeface="Times New Roman" panose="02020603050405020304" pitchFamily="18" charset="0"/>
               <a:ea typeface="宋体" panose="02010600030101010101" pitchFamily="2" charset="-122"/>
               <a:cs typeface="Times New Roman" panose="02020603050405020304" pitchFamily="18" charset="0"/>
             </a:endParaRPr>
           </a:p>
           <a:p>
-            <a:pPr indent="0">
-              <a:buFont typeface="Wingdings" panose="05000000000000000000" charset="0"/>
-              <a:buNone/>
-            </a:pPr>
-            <a:r>
-              <a:rPr lang="zh-CN" altLang="en-US" sz="2000">
-                <a:latin typeface="Times New Roman" panose="02020603050405020304" pitchFamily="18" charset="0"/>
-                <a:ea typeface="宋体" panose="02010600030101010101" pitchFamily="2" charset="-122"/>
-                <a:cs typeface="Times New Roman" panose="02020603050405020304" pitchFamily="18" charset="0"/>
-              </a:rPr>
-              <a:t>大体要求：</a:t>
-            </a:r>
-          </a:p>
-          <a:p>
-            <a:pPr marL="285750" indent="-285750">
-              <a:buFont typeface="Wingdings" panose="05000000000000000000" charset="0"/>
+            <a:pPr marL="342900" indent="-342900">
+              <a:buFont typeface="Wingdings" panose="05000000000000000000" pitchFamily="2" charset="2"/>
               <a:buChar char="Ø"/>
             </a:pPr>
             <a:r>
-              <a:rPr lang="zh-CN" altLang="en-US" sz="2000">
-                <a:latin typeface="Times New Roman" panose="02020603050405020304" pitchFamily="18" charset="0"/>
-                <a:ea typeface="宋体" panose="02010600030101010101" pitchFamily="2" charset="-122"/>
-                <a:cs typeface="Times New Roman" panose="02020603050405020304" pitchFamily="18" charset="0"/>
-              </a:rPr>
-              <a:t>抗体：特异性、稳定性、内化</a:t>
-            </a:r>
-          </a:p>
-          <a:p>
-            <a:pPr marL="285750" indent="-285750">
-              <a:buFont typeface="Wingdings" panose="05000000000000000000" charset="0"/>
-              <a:buChar char="Ø"/>
-            </a:pPr>
-            <a:r>
-              <a:rPr lang="zh-CN" altLang="en-US" sz="2000">
-                <a:latin typeface="Times New Roman" panose="02020603050405020304" pitchFamily="18" charset="0"/>
-                <a:ea typeface="宋体" panose="02010600030101010101" pitchFamily="2" charset="-122"/>
-                <a:cs typeface="Times New Roman" panose="02020603050405020304" pitchFamily="18" charset="0"/>
-              </a:rPr>
-              <a:t>连接方式与连接子：稳定性、可控释放、亲水性</a:t>
-            </a:r>
-          </a:p>
-          <a:p>
-            <a:pPr marL="285750" indent="-285750">
-              <a:buFont typeface="Wingdings" panose="05000000000000000000" charset="0"/>
-              <a:buChar char="Ø"/>
-            </a:pPr>
-            <a:r>
-              <a:rPr lang="zh-CN" altLang="en-US" sz="2000">
-                <a:latin typeface="Times New Roman" panose="02020603050405020304" pitchFamily="18" charset="0"/>
-                <a:ea typeface="宋体" panose="02010600030101010101" pitchFamily="2" charset="-122"/>
-                <a:cs typeface="Times New Roman" panose="02020603050405020304" pitchFamily="18" charset="0"/>
-              </a:rPr>
-              <a:t>药物：高效力、稳定性、潜在旁观者效应。</a:t>
-            </a:r>
-          </a:p>
-          <a:p>
-            <a:endParaRPr lang="zh-CN" altLang="en-US" sz="2000">
+              <a:rPr lang="en-US" altLang="zh-CN" sz="2000" dirty="0">
+                <a:latin typeface="Times New Roman" panose="02020603050405020304" pitchFamily="18" charset="0"/>
+                <a:ea typeface="宋体" panose="02010600030101010101" pitchFamily="2" charset="-122"/>
+                <a:cs typeface="Times New Roman" panose="02020603050405020304" pitchFamily="18" charset="0"/>
+              </a:rPr>
+              <a:t>ADC</a:t>
+            </a:r>
+            <a:r>
+              <a:rPr lang="zh-CN" altLang="en-US" sz="2000" dirty="0">
+                <a:latin typeface="Times New Roman" panose="02020603050405020304" pitchFamily="18" charset="0"/>
+                <a:ea typeface="宋体" panose="02010600030101010101" pitchFamily="2" charset="-122"/>
+                <a:cs typeface="Times New Roman" panose="02020603050405020304" pitchFamily="18" charset="0"/>
+              </a:rPr>
+              <a:t>的应用：</a:t>
+            </a:r>
+            <a:endParaRPr lang="en-US" altLang="zh-CN" sz="2000" dirty="0">
               <a:latin typeface="Times New Roman" panose="02020603050405020304" pitchFamily="18" charset="0"/>
               <a:ea typeface="宋体" panose="02010600030101010101" pitchFamily="2" charset="-122"/>
               <a:cs typeface="Times New Roman" panose="02020603050405020304" pitchFamily="18" charset="0"/>
             </a:endParaRPr>
           </a:p>
           <a:p>
-            <a:endParaRPr lang="zh-CN" altLang="en-US" sz="2000">
+            <a:r>
+              <a:rPr lang="en-US" altLang="zh-CN" sz="2000" dirty="0">
+                <a:latin typeface="Times New Roman" panose="02020603050405020304" pitchFamily="18" charset="0"/>
+                <a:ea typeface="宋体" panose="02010600030101010101" pitchFamily="2" charset="-122"/>
+                <a:cs typeface="Times New Roman" panose="02020603050405020304" pitchFamily="18" charset="0"/>
+              </a:rPr>
+              <a:t>     </a:t>
+            </a:r>
+            <a:r>
+              <a:rPr lang="zh-CN" altLang="en-US" sz="2000" dirty="0">
+                <a:latin typeface="Times New Roman" panose="02020603050405020304" pitchFamily="18" charset="0"/>
+                <a:ea typeface="宋体" panose="02010600030101010101" pitchFamily="2" charset="-122"/>
+                <a:cs typeface="Times New Roman" panose="02020603050405020304" pitchFamily="18" charset="0"/>
+              </a:rPr>
+              <a:t>核心应用场景</a:t>
+            </a:r>
+            <a:r>
+              <a:rPr lang="en-US" altLang="zh-CN" sz="2000" dirty="0">
+                <a:latin typeface="Times New Roman" panose="02020603050405020304" pitchFamily="18" charset="0"/>
+                <a:ea typeface="宋体" panose="02010600030101010101" pitchFamily="2" charset="-122"/>
+                <a:cs typeface="Times New Roman" panose="02020603050405020304" pitchFamily="18" charset="0"/>
+              </a:rPr>
+              <a:t>——</a:t>
+            </a:r>
+            <a:r>
+              <a:rPr lang="zh-CN" altLang="en-US" sz="2000" dirty="0">
+                <a:latin typeface="Times New Roman" panose="02020603050405020304" pitchFamily="18" charset="0"/>
+                <a:ea typeface="宋体" panose="02010600030101010101" pitchFamily="2" charset="-122"/>
+                <a:cs typeface="Times New Roman" panose="02020603050405020304" pitchFamily="18" charset="0"/>
+              </a:rPr>
+              <a:t>肿瘤治疗</a:t>
+            </a:r>
+            <a:r>
+              <a:rPr lang="en-US" altLang="zh-CN" sz="2000" dirty="0">
+                <a:latin typeface="Times New Roman" panose="02020603050405020304" pitchFamily="18" charset="0"/>
+                <a:ea typeface="宋体" panose="02010600030101010101" pitchFamily="2" charset="-122"/>
+                <a:cs typeface="Times New Roman" panose="02020603050405020304" pitchFamily="18" charset="0"/>
+              </a:rPr>
+              <a:t>	</a:t>
+            </a:r>
+          </a:p>
+          <a:p>
+            <a:endParaRPr lang="zh-CN" altLang="en-US" sz="2000" dirty="0">
+              <a:latin typeface="Times New Roman" panose="02020603050405020304" pitchFamily="18" charset="0"/>
+              <a:ea typeface="宋体" panose="02010600030101010101" pitchFamily="2" charset="-122"/>
+              <a:cs typeface="Times New Roman" panose="02020603050405020304" pitchFamily="18" charset="0"/>
+            </a:endParaRPr>
+          </a:p>
+          <a:p>
+            <a:endParaRPr lang="zh-CN" altLang="en-US" sz="2000" dirty="0">
               <a:latin typeface="Times New Roman" panose="02020603050405020304" pitchFamily="18" charset="0"/>
               <a:ea typeface="宋体" panose="02010600030101010101" pitchFamily="2" charset="-122"/>
               <a:cs typeface="Times New Roman" panose="02020603050405020304" pitchFamily="18" charset="0"/>
@@ -15448,7 +15795,7 @@
           <p:nvPr/>
         </p:nvPicPr>
         <p:blipFill>
-          <a:blip r:embed="rId3"/>
+          <a:blip r:embed="rId4"/>
           <a:stretch>
             <a:fillRect/>
           </a:stretch>
@@ -15472,7 +15819,7 @@
           <p:nvPr/>
         </p:nvPicPr>
         <p:blipFill>
-          <a:blip r:embed="rId4">
+          <a:blip r:embed="rId5">
             <a:clrChange>
               <a:clrFrom>
                 <a:srgbClr val="F9FAFB">
@@ -15510,7 +15857,7 @@
           <p:nvPr/>
         </p:nvPicPr>
         <p:blipFill>
-          <a:blip r:embed="rId5">
+          <a:blip r:embed="rId6">
             <a:clrChange>
               <a:clrFrom>
                 <a:srgbClr val="F9FAFB">
@@ -15548,7 +15895,7 @@
           <p:nvPr/>
         </p:nvPicPr>
         <p:blipFill>
-          <a:blip r:embed="rId6">
+          <a:blip r:embed="rId7">
             <a:clrChange>
               <a:clrFrom>
                 <a:srgbClr val="F9FAFB">
@@ -15586,7 +15933,7 @@
           <p:nvPr/>
         </p:nvPicPr>
         <p:blipFill>
-          <a:blip r:embed="rId7">
+          <a:blip r:embed="rId8">
             <a:clrChange>
               <a:clrFrom>
                 <a:srgbClr val="F9FAFB">
@@ -15624,7 +15971,7 @@
           <p:nvPr/>
         </p:nvPicPr>
         <p:blipFill>
-          <a:blip r:embed="rId8">
+          <a:blip r:embed="rId9">
             <a:clrChange>
               <a:clrFrom>
                 <a:srgbClr val="F9FAFB">

</xml_diff>

<commit_message>
vault backup: 2025-10-24 20:58:25
</commit_message>
<xml_diff>
--- a/生物分离工程/第十组汇报ppt.pptx
+++ b/生物分离工程/第十组汇报ppt.pptx
@@ -1187,15 +1187,7 @@
             </a:r>
             <a:r>
               <a:rPr lang="zh-CN" altLang="en-US" dirty="0"/>
-              <a:t>，作为一种靶向癌症疗法，利用抗体的特异性像“生物导弹”一样精准识别肿瘤细胞，并将高效的细胞毒素递送至其内部</a:t>
-            </a:r>
-            <a:r>
-              <a:rPr lang="zh-CN" altLang="en-US"/>
-              <a:t>进行杀伤，</a:t>
-            </a:r>
-            <a:r>
-              <a:rPr lang="zh-CN" altLang="en-US" dirty="0"/>
-              <a:t>实现对癌细胞的精准杀伤，同时降低对健康组织的副作用。</a:t>
+              <a:t>，作为一种靶向癌症疗法，利用抗体的特异性像“生物导弹”一样精准识别肿瘤细胞，并将高效的细胞毒素递送至其内部进行杀伤，实现对癌细胞的精准杀伤，同时降低对健康组织的副作用。</a:t>
             </a:r>
           </a:p>
           <a:p>
@@ -1233,6 +1225,806 @@
     <p:extLst>
       <p:ext uri="{BB962C8B-B14F-4D97-AF65-F5344CB8AC3E}">
         <p14:creationId xmlns:p14="http://schemas.microsoft.com/office/powerpoint/2010/main" val="1989410614"/>
+      </p:ext>
+    </p:extLst>
+  </p:cSld>
+  <p:clrMapOvr>
+    <a:masterClrMapping/>
+  </p:clrMapOvr>
+</p:notes>
+</file>
+
+<file path=ppt/notesSlides/notesSlide5.xml><?xml version="1.0" encoding="utf-8"?>
+<p:notes xmlns:a="http://schemas.openxmlformats.org/drawingml/2006/main" xmlns:r="http://schemas.openxmlformats.org/officeDocument/2006/relationships" xmlns:p="http://schemas.openxmlformats.org/presentationml/2006/main">
+  <p:cSld>
+    <p:spTree>
+      <p:nvGrpSpPr>
+        <p:cNvPr id="1" name=""/>
+        <p:cNvGrpSpPr/>
+        <p:nvPr/>
+      </p:nvGrpSpPr>
+      <p:grpSpPr>
+        <a:xfrm>
+          <a:off x="0" y="0"/>
+          <a:ext cx="0" cy="0"/>
+          <a:chOff x="0" y="0"/>
+          <a:chExt cx="0" cy="0"/>
+        </a:xfrm>
+      </p:grpSpPr>
+      <p:sp>
+        <p:nvSpPr>
+          <p:cNvPr id="2" name="幻灯片图像占位符 1"/>
+          <p:cNvSpPr>
+            <a:spLocks noGrp="1" noRot="1" noChangeAspect="1"/>
+          </p:cNvSpPr>
+          <p:nvPr>
+            <p:ph type="sldImg"/>
+          </p:nvPr>
+        </p:nvSpPr>
+        <p:spPr/>
+      </p:sp>
+      <p:sp>
+        <p:nvSpPr>
+          <p:cNvPr id="3" name="备注占位符 2"/>
+          <p:cNvSpPr>
+            <a:spLocks noGrp="1"/>
+          </p:cNvSpPr>
+          <p:nvPr>
+            <p:ph type="body" idx="1"/>
+          </p:nvPr>
+        </p:nvSpPr>
+        <p:spPr/>
+        <p:txBody>
+          <a:bodyPr/>
+          <a:lstStyle/>
+          <a:p>
+            <a:r>
+              <a:rPr lang="zh-CN" altLang="en-US" dirty="0"/>
+              <a:t>在正式介绍</a:t>
+            </a:r>
+            <a:r>
+              <a:rPr lang="en-US" altLang="zh-CN" dirty="0"/>
+              <a:t>ADC</a:t>
+            </a:r>
+            <a:r>
+              <a:rPr lang="zh-CN" altLang="en-US" dirty="0"/>
+              <a:t>的合成纯化之前，我们先了解它的前体物质</a:t>
+            </a:r>
+            <a:r>
+              <a:rPr lang="en-US" altLang="zh-CN" dirty="0" err="1"/>
+              <a:t>mAb</a:t>
+            </a:r>
+            <a:r>
+              <a:rPr lang="zh-CN" altLang="en-US" dirty="0"/>
+              <a:t>是如何制备的：</a:t>
+            </a:r>
+            <a:endParaRPr lang="en-US" altLang="zh-CN" dirty="0"/>
+          </a:p>
+          <a:p>
+            <a:endParaRPr lang="en-US" altLang="zh-CN" dirty="0"/>
+          </a:p>
+          <a:p>
+            <a:r>
+              <a:rPr lang="zh-CN" altLang="en-US" dirty="0"/>
+              <a:t>下面内容复述</a:t>
+            </a:r>
+            <a:r>
+              <a:rPr lang="en-US" altLang="zh-CN" dirty="0"/>
+              <a:t>ppt</a:t>
+            </a:r>
+            <a:endParaRPr lang="zh-CN" altLang="en-US" dirty="0"/>
+          </a:p>
+        </p:txBody>
+      </p:sp>
+      <p:sp>
+        <p:nvSpPr>
+          <p:cNvPr id="4" name="灯片编号占位符 3"/>
+          <p:cNvSpPr>
+            <a:spLocks noGrp="1"/>
+          </p:cNvSpPr>
+          <p:nvPr>
+            <p:ph type="sldNum" sz="quarter" idx="5"/>
+          </p:nvPr>
+        </p:nvSpPr>
+        <p:spPr/>
+        <p:txBody>
+          <a:bodyPr/>
+          <a:lstStyle/>
+          <a:p>
+            <a:fld id="{337F53EF-5364-44E3-BFA2-84231755F7E3}" type="slidenum">
+              <a:rPr lang="zh-CN" altLang="en-US" smtClean="0"/>
+              <a:t>6</a:t>
+            </a:fld>
+            <a:endParaRPr lang="zh-CN" altLang="en-US"/>
+          </a:p>
+        </p:txBody>
+      </p:sp>
+    </p:spTree>
+    <p:extLst>
+      <p:ext uri="{BB962C8B-B14F-4D97-AF65-F5344CB8AC3E}">
+        <p14:creationId xmlns:p14="http://schemas.microsoft.com/office/powerpoint/2010/main" val="759479609"/>
+      </p:ext>
+    </p:extLst>
+  </p:cSld>
+  <p:clrMapOvr>
+    <a:masterClrMapping/>
+  </p:clrMapOvr>
+</p:notes>
+</file>
+
+<file path=ppt/notesSlides/notesSlide6.xml><?xml version="1.0" encoding="utf-8"?>
+<p:notes xmlns:a="http://schemas.openxmlformats.org/drawingml/2006/main" xmlns:r="http://schemas.openxmlformats.org/officeDocument/2006/relationships" xmlns:p="http://schemas.openxmlformats.org/presentationml/2006/main">
+  <p:cSld>
+    <p:spTree>
+      <p:nvGrpSpPr>
+        <p:cNvPr id="1" name=""/>
+        <p:cNvGrpSpPr/>
+        <p:nvPr/>
+      </p:nvGrpSpPr>
+      <p:grpSpPr>
+        <a:xfrm>
+          <a:off x="0" y="0"/>
+          <a:ext cx="0" cy="0"/>
+          <a:chOff x="0" y="0"/>
+          <a:chExt cx="0" cy="0"/>
+        </a:xfrm>
+      </p:grpSpPr>
+      <p:sp>
+        <p:nvSpPr>
+          <p:cNvPr id="2" name="幻灯片图像占位符 1"/>
+          <p:cNvSpPr>
+            <a:spLocks noGrp="1" noRot="1" noChangeAspect="1"/>
+          </p:cNvSpPr>
+          <p:nvPr>
+            <p:ph type="sldImg"/>
+          </p:nvPr>
+        </p:nvSpPr>
+        <p:spPr/>
+      </p:sp>
+      <p:sp>
+        <p:nvSpPr>
+          <p:cNvPr id="3" name="备注占位符 2"/>
+          <p:cNvSpPr>
+            <a:spLocks noGrp="1"/>
+          </p:cNvSpPr>
+          <p:nvPr>
+            <p:ph type="body" idx="1"/>
+          </p:nvPr>
+        </p:nvSpPr>
+        <p:spPr/>
+        <p:txBody>
+          <a:bodyPr/>
+          <a:lstStyle/>
+          <a:p>
+            <a:r>
+              <a:rPr lang="zh-CN" altLang="en-US" dirty="0"/>
+              <a:t>接下来，是</a:t>
+            </a:r>
+            <a:r>
+              <a:rPr lang="en-US" altLang="zh-CN" dirty="0"/>
+              <a:t>ADC</a:t>
+            </a:r>
+            <a:r>
+              <a:rPr lang="zh-CN" altLang="en-US" dirty="0"/>
+              <a:t>的合成纯化流程</a:t>
+            </a:r>
+            <a:endParaRPr lang="en-US" altLang="zh-CN" dirty="0"/>
+          </a:p>
+          <a:p>
+            <a:endParaRPr lang="en-US" altLang="zh-CN" dirty="0"/>
+          </a:p>
+          <a:p>
+            <a:r>
+              <a:rPr lang="zh-CN" altLang="en-US" dirty="0"/>
+              <a:t>然后读</a:t>
+            </a:r>
+            <a:r>
+              <a:rPr lang="en-US" altLang="zh-CN" dirty="0"/>
+              <a:t>ppt</a:t>
+            </a:r>
+            <a:r>
+              <a:rPr lang="zh-CN" altLang="en-US" dirty="0"/>
+              <a:t>：</a:t>
+            </a:r>
+            <a:endParaRPr lang="en-US" altLang="zh-CN" dirty="0"/>
+          </a:p>
+          <a:p>
+            <a:endParaRPr lang="en-US" altLang="zh-CN" dirty="0"/>
+          </a:p>
+          <a:p>
+            <a:pPr marL="342900" indent="-342900">
+              <a:buFont typeface="Wingdings" panose="05000000000000000000" charset="0"/>
+              <a:buChar char="Ø"/>
+            </a:pPr>
+            <a:r>
+              <a:rPr lang="en-US" altLang="zh-CN" sz="1200" dirty="0" err="1">
+                <a:latin typeface="Times New Roman" panose="02020603050405020304" pitchFamily="18" charset="0"/>
+                <a:ea typeface="宋体" panose="02010600030101010101" pitchFamily="2" charset="-122"/>
+                <a:cs typeface="Times New Roman" panose="02020603050405020304" pitchFamily="18" charset="0"/>
+              </a:rPr>
+              <a:t>mAb</a:t>
+            </a:r>
+            <a:r>
+              <a:rPr lang="zh-CN" altLang="en-US" sz="1200" dirty="0">
+                <a:latin typeface="Times New Roman" panose="02020603050405020304" pitchFamily="18" charset="0"/>
+                <a:ea typeface="宋体" panose="02010600030101010101" pitchFamily="2" charset="-122"/>
+                <a:cs typeface="Times New Roman" panose="02020603050405020304" pitchFamily="18" charset="0"/>
+              </a:rPr>
+              <a:t>先经</a:t>
+            </a:r>
+            <a:r>
+              <a:rPr lang="en-US" altLang="zh-CN" sz="1200" dirty="0">
+                <a:latin typeface="Times New Roman" panose="02020603050405020304" pitchFamily="18" charset="0"/>
+                <a:ea typeface="宋体" panose="02010600030101010101" pitchFamily="2" charset="-122"/>
+                <a:cs typeface="Times New Roman" panose="02020603050405020304" pitchFamily="18" charset="0"/>
+              </a:rPr>
+              <a:t>TFF</a:t>
+            </a:r>
+            <a:r>
+              <a:rPr lang="zh-CN" altLang="en-US" sz="1200" dirty="0">
+                <a:latin typeface="Times New Roman" panose="02020603050405020304" pitchFamily="18" charset="0"/>
+                <a:ea typeface="宋体" panose="02010600030101010101" pitchFamily="2" charset="-122"/>
+                <a:cs typeface="Times New Roman" panose="02020603050405020304" pitchFamily="18" charset="0"/>
+              </a:rPr>
+              <a:t>进行缓冲液置换或稀释，将体系调整为适配后续反应的状态。</a:t>
+            </a:r>
+          </a:p>
+          <a:p>
+            <a:pPr marL="342900" indent="-342900">
+              <a:buFont typeface="Wingdings" panose="05000000000000000000" charset="0"/>
+              <a:buChar char="Ø"/>
+            </a:pPr>
+            <a:r>
+              <a:rPr lang="zh-CN" altLang="en-US" sz="1200" dirty="0">
+                <a:latin typeface="Times New Roman" panose="02020603050405020304" pitchFamily="18" charset="0"/>
+                <a:ea typeface="宋体" panose="02010600030101010101" pitchFamily="2" charset="-122"/>
+                <a:cs typeface="Times New Roman" panose="02020603050405020304" pitchFamily="18" charset="0"/>
+              </a:rPr>
+              <a:t>对</a:t>
+            </a:r>
+            <a:r>
+              <a:rPr lang="en-US" altLang="zh-CN" sz="1200" dirty="0" err="1">
+                <a:latin typeface="Times New Roman" panose="02020603050405020304" pitchFamily="18" charset="0"/>
+                <a:ea typeface="宋体" panose="02010600030101010101" pitchFamily="2" charset="-122"/>
+                <a:cs typeface="Times New Roman" panose="02020603050405020304" pitchFamily="18" charset="0"/>
+              </a:rPr>
+              <a:t>mAb</a:t>
+            </a:r>
+            <a:r>
+              <a:rPr lang="zh-CN" altLang="en-US" sz="1200" dirty="0">
+                <a:latin typeface="Times New Roman" panose="02020603050405020304" pitchFamily="18" charset="0"/>
+                <a:ea typeface="宋体" panose="02010600030101010101" pitchFamily="2" charset="-122"/>
+                <a:cs typeface="Times New Roman" panose="02020603050405020304" pitchFamily="18" charset="0"/>
+              </a:rPr>
+              <a:t>进行修饰（如</a:t>
+            </a:r>
+            <a:r>
+              <a:rPr lang="en-US" altLang="zh-CN" sz="1200" dirty="0">
+                <a:latin typeface="Times New Roman" panose="02020603050405020304" pitchFamily="18" charset="0"/>
+                <a:ea typeface="宋体" panose="02010600030101010101" pitchFamily="2" charset="-122"/>
+                <a:cs typeface="Times New Roman" panose="02020603050405020304" pitchFamily="18" charset="0"/>
+              </a:rPr>
+              <a:t>TCEP</a:t>
+            </a:r>
+            <a:r>
+              <a:rPr lang="zh-CN" altLang="en-US" sz="1200" dirty="0">
+                <a:latin typeface="Times New Roman" panose="02020603050405020304" pitchFamily="18" charset="0"/>
+                <a:ea typeface="宋体" panose="02010600030101010101" pitchFamily="2" charset="-122"/>
+                <a:cs typeface="Times New Roman" panose="02020603050405020304" pitchFamily="18" charset="0"/>
+              </a:rPr>
+              <a:t>还原）得到抗体中间体，与细胞毒性载荷偶联后生成粗制</a:t>
+            </a:r>
+            <a:r>
+              <a:rPr lang="en-US" altLang="zh-CN" sz="1200" dirty="0">
+                <a:latin typeface="Times New Roman" panose="02020603050405020304" pitchFamily="18" charset="0"/>
+                <a:ea typeface="宋体" panose="02010600030101010101" pitchFamily="2" charset="-122"/>
+                <a:cs typeface="Times New Roman" panose="02020603050405020304" pitchFamily="18" charset="0"/>
+              </a:rPr>
+              <a:t>ADC</a:t>
+            </a:r>
+            <a:r>
+              <a:rPr lang="zh-CN" altLang="en-US" sz="1200" dirty="0">
+                <a:latin typeface="Times New Roman" panose="02020603050405020304" pitchFamily="18" charset="0"/>
+                <a:ea typeface="宋体" panose="02010600030101010101" pitchFamily="2" charset="-122"/>
+                <a:cs typeface="Times New Roman" panose="02020603050405020304" pitchFamily="18" charset="0"/>
+              </a:rPr>
+              <a:t>。</a:t>
+            </a:r>
+          </a:p>
+          <a:p>
+            <a:pPr marL="342900" indent="-342900">
+              <a:buFont typeface="Wingdings" panose="05000000000000000000" charset="0"/>
+              <a:buChar char="Ø"/>
+            </a:pPr>
+            <a:r>
+              <a:rPr lang="zh-CN" altLang="en-US" sz="1200" dirty="0">
+                <a:latin typeface="Times New Roman" panose="02020603050405020304" pitchFamily="18" charset="0"/>
+                <a:ea typeface="宋体" panose="02010600030101010101" pitchFamily="2" charset="-122"/>
+                <a:cs typeface="Times New Roman" panose="02020603050405020304" pitchFamily="18" charset="0"/>
+              </a:rPr>
+              <a:t>粗制</a:t>
+            </a:r>
+            <a:r>
+              <a:rPr lang="en-US" altLang="zh-CN" sz="1200" dirty="0">
+                <a:latin typeface="Times New Roman" panose="02020603050405020304" pitchFamily="18" charset="0"/>
+                <a:ea typeface="宋体" panose="02010600030101010101" pitchFamily="2" charset="-122"/>
+                <a:cs typeface="Times New Roman" panose="02020603050405020304" pitchFamily="18" charset="0"/>
+              </a:rPr>
+              <a:t>ADC</a:t>
+            </a:r>
+            <a:r>
+              <a:rPr lang="zh-CN" altLang="en-US" sz="1200" dirty="0">
+                <a:latin typeface="Times New Roman" panose="02020603050405020304" pitchFamily="18" charset="0"/>
+                <a:ea typeface="宋体" panose="02010600030101010101" pitchFamily="2" charset="-122"/>
+                <a:cs typeface="Times New Roman" panose="02020603050405020304" pitchFamily="18" charset="0"/>
+              </a:rPr>
+              <a:t>可通过</a:t>
+            </a:r>
+            <a:r>
+              <a:rPr lang="en-US" altLang="zh-CN" sz="1200" dirty="0">
+                <a:latin typeface="Times New Roman" panose="02020603050405020304" pitchFamily="18" charset="0"/>
+                <a:ea typeface="宋体" panose="02010600030101010101" pitchFamily="2" charset="-122"/>
+                <a:cs typeface="Times New Roman" panose="02020603050405020304" pitchFamily="18" charset="0"/>
+              </a:rPr>
+              <a:t>TFF</a:t>
+            </a:r>
+            <a:r>
+              <a:rPr lang="zh-CN" altLang="en-US" sz="1200" dirty="0">
+                <a:latin typeface="Times New Roman" panose="02020603050405020304" pitchFamily="18" charset="0"/>
+                <a:ea typeface="宋体" panose="02010600030101010101" pitchFamily="2" charset="-122"/>
+                <a:cs typeface="Times New Roman" panose="02020603050405020304" pitchFamily="18" charset="0"/>
+              </a:rPr>
+              <a:t>直接纯化，或经色谱（如</a:t>
+            </a:r>
+            <a:r>
+              <a:rPr lang="en-US" altLang="zh-CN" sz="1200" dirty="0">
+                <a:latin typeface="Times New Roman" panose="02020603050405020304" pitchFamily="18" charset="0"/>
+                <a:ea typeface="宋体" panose="02010600030101010101" pitchFamily="2" charset="-122"/>
+                <a:cs typeface="Times New Roman" panose="02020603050405020304" pitchFamily="18" charset="0"/>
+              </a:rPr>
+              <a:t>SEC</a:t>
+            </a:r>
+            <a:r>
+              <a:rPr lang="zh-CN" altLang="en-US" sz="1200" dirty="0">
+                <a:latin typeface="Times New Roman" panose="02020603050405020304" pitchFamily="18" charset="0"/>
+                <a:ea typeface="宋体" panose="02010600030101010101" pitchFamily="2" charset="-122"/>
+                <a:cs typeface="Times New Roman" panose="02020603050405020304" pitchFamily="18" charset="0"/>
+              </a:rPr>
+              <a:t>、</a:t>
+            </a:r>
+            <a:r>
+              <a:rPr lang="en-US" altLang="zh-CN" sz="1200" dirty="0">
+                <a:latin typeface="Times New Roman" panose="02020603050405020304" pitchFamily="18" charset="0"/>
+                <a:ea typeface="宋体" panose="02010600030101010101" pitchFamily="2" charset="-122"/>
+                <a:cs typeface="Times New Roman" panose="02020603050405020304" pitchFamily="18" charset="0"/>
+              </a:rPr>
+              <a:t>HIC</a:t>
+            </a:r>
+            <a:r>
+              <a:rPr lang="zh-CN" altLang="en-US" sz="1200" dirty="0">
+                <a:latin typeface="Times New Roman" panose="02020603050405020304" pitchFamily="18" charset="0"/>
+                <a:ea typeface="宋体" panose="02010600030101010101" pitchFamily="2" charset="-122"/>
+                <a:cs typeface="Times New Roman" panose="02020603050405020304" pitchFamily="18" charset="0"/>
+              </a:rPr>
+              <a:t>膜色谱）处理纯化。</a:t>
+            </a:r>
+          </a:p>
+          <a:p>
+            <a:pPr marL="342900" indent="-342900">
+              <a:buFont typeface="Wingdings" panose="05000000000000000000" charset="0"/>
+              <a:buChar char="Ø"/>
+            </a:pPr>
+            <a:r>
+              <a:rPr lang="zh-CN" altLang="en-US" sz="1200" dirty="0">
+                <a:latin typeface="Times New Roman" panose="02020603050405020304" pitchFamily="18" charset="0"/>
+                <a:ea typeface="宋体" panose="02010600030101010101" pitchFamily="2" charset="-122"/>
+                <a:cs typeface="Times New Roman" panose="02020603050405020304" pitchFamily="18" charset="0"/>
+              </a:rPr>
+              <a:t>最终再经</a:t>
+            </a:r>
+            <a:r>
+              <a:rPr lang="en-US" altLang="zh-CN" sz="1200" dirty="0">
+                <a:latin typeface="Times New Roman" panose="02020603050405020304" pitchFamily="18" charset="0"/>
+                <a:ea typeface="宋体" panose="02010600030101010101" pitchFamily="2" charset="-122"/>
+                <a:cs typeface="Times New Roman" panose="02020603050405020304" pitchFamily="18" charset="0"/>
+              </a:rPr>
+              <a:t>TFF</a:t>
+            </a:r>
+            <a:r>
+              <a:rPr lang="zh-CN" altLang="en-US" sz="1200" dirty="0">
+                <a:latin typeface="Times New Roman" panose="02020603050405020304" pitchFamily="18" charset="0"/>
+                <a:ea typeface="宋体" panose="02010600030101010101" pitchFamily="2" charset="-122"/>
+                <a:cs typeface="Times New Roman" panose="02020603050405020304" pitchFamily="18" charset="0"/>
+              </a:rPr>
+              <a:t>完成缓冲液置换与制剂调配，得到成品</a:t>
+            </a:r>
+            <a:r>
+              <a:rPr lang="en-US" altLang="zh-CN" sz="1200" dirty="0">
+                <a:latin typeface="Times New Roman" panose="02020603050405020304" pitchFamily="18" charset="0"/>
+                <a:ea typeface="宋体" panose="02010600030101010101" pitchFamily="2" charset="-122"/>
+                <a:cs typeface="Times New Roman" panose="02020603050405020304" pitchFamily="18" charset="0"/>
+              </a:rPr>
+              <a:t>ADC</a:t>
+            </a:r>
+            <a:r>
+              <a:rPr lang="zh-CN" altLang="en-US" sz="1200" dirty="0">
+                <a:latin typeface="Times New Roman" panose="02020603050405020304" pitchFamily="18" charset="0"/>
+                <a:ea typeface="宋体" panose="02010600030101010101" pitchFamily="2" charset="-122"/>
+                <a:cs typeface="Times New Roman" panose="02020603050405020304" pitchFamily="18" charset="0"/>
+              </a:rPr>
+              <a:t>。</a:t>
+            </a:r>
+          </a:p>
+          <a:p>
+            <a:endParaRPr lang="zh-CN" altLang="en-US" dirty="0"/>
+          </a:p>
+        </p:txBody>
+      </p:sp>
+      <p:sp>
+        <p:nvSpPr>
+          <p:cNvPr id="4" name="灯片编号占位符 3"/>
+          <p:cNvSpPr>
+            <a:spLocks noGrp="1"/>
+          </p:cNvSpPr>
+          <p:nvPr>
+            <p:ph type="sldNum" sz="quarter" idx="5"/>
+          </p:nvPr>
+        </p:nvSpPr>
+        <p:spPr/>
+        <p:txBody>
+          <a:bodyPr/>
+          <a:lstStyle/>
+          <a:p>
+            <a:fld id="{337F53EF-5364-44E3-BFA2-84231755F7E3}" type="slidenum">
+              <a:rPr lang="zh-CN" altLang="en-US" smtClean="0"/>
+              <a:t>7</a:t>
+            </a:fld>
+            <a:endParaRPr lang="zh-CN" altLang="en-US"/>
+          </a:p>
+        </p:txBody>
+      </p:sp>
+    </p:spTree>
+    <p:extLst>
+      <p:ext uri="{BB962C8B-B14F-4D97-AF65-F5344CB8AC3E}">
+        <p14:creationId xmlns:p14="http://schemas.microsoft.com/office/powerpoint/2010/main" val="1470313078"/>
+      </p:ext>
+    </p:extLst>
+  </p:cSld>
+  <p:clrMapOvr>
+    <a:masterClrMapping/>
+  </p:clrMapOvr>
+</p:notes>
+</file>
+
+<file path=ppt/notesSlides/notesSlide7.xml><?xml version="1.0" encoding="utf-8"?>
+<p:notes xmlns:a="http://schemas.openxmlformats.org/drawingml/2006/main" xmlns:r="http://schemas.openxmlformats.org/officeDocument/2006/relationships" xmlns:p="http://schemas.openxmlformats.org/presentationml/2006/main">
+  <p:cSld>
+    <p:spTree>
+      <p:nvGrpSpPr>
+        <p:cNvPr id="1" name=""/>
+        <p:cNvGrpSpPr/>
+        <p:nvPr/>
+      </p:nvGrpSpPr>
+      <p:grpSpPr>
+        <a:xfrm>
+          <a:off x="0" y="0"/>
+          <a:ext cx="0" cy="0"/>
+          <a:chOff x="0" y="0"/>
+          <a:chExt cx="0" cy="0"/>
+        </a:xfrm>
+      </p:grpSpPr>
+      <p:sp>
+        <p:nvSpPr>
+          <p:cNvPr id="2" name="幻灯片图像占位符 1"/>
+          <p:cNvSpPr>
+            <a:spLocks noGrp="1" noRot="1" noChangeAspect="1"/>
+          </p:cNvSpPr>
+          <p:nvPr>
+            <p:ph type="sldImg"/>
+          </p:nvPr>
+        </p:nvSpPr>
+        <p:spPr/>
+      </p:sp>
+      <p:sp>
+        <p:nvSpPr>
+          <p:cNvPr id="3" name="备注占位符 2"/>
+          <p:cNvSpPr>
+            <a:spLocks noGrp="1"/>
+          </p:cNvSpPr>
+          <p:nvPr>
+            <p:ph type="body" idx="1"/>
+          </p:nvPr>
+        </p:nvSpPr>
+        <p:spPr/>
+        <p:txBody>
+          <a:bodyPr/>
+          <a:lstStyle/>
+          <a:p>
+            <a:r>
+              <a:rPr lang="zh-CN" altLang="en-US" sz="1200" dirty="0">
+                <a:latin typeface="Times New Roman" panose="02020603050405020304" pitchFamily="18" charset="0"/>
+                <a:ea typeface="宋体" panose="02010600030101010101" pitchFamily="2" charset="-122"/>
+                <a:cs typeface="Times New Roman" panose="02020603050405020304" pitchFamily="18" charset="0"/>
+              </a:rPr>
+              <a:t>在了解了基本的制作工艺后，我们分离纯化要解决的就是以下几个问题：</a:t>
+            </a:r>
+            <a:endParaRPr lang="en-US" altLang="zh-CN" sz="1200" dirty="0">
+              <a:latin typeface="Times New Roman" panose="02020603050405020304" pitchFamily="18" charset="0"/>
+              <a:ea typeface="宋体" panose="02010600030101010101" pitchFamily="2" charset="-122"/>
+              <a:cs typeface="Times New Roman" panose="02020603050405020304" pitchFamily="18" charset="0"/>
+            </a:endParaRPr>
+          </a:p>
+          <a:p>
+            <a:endParaRPr lang="zh-CN" altLang="en-US" sz="1200" dirty="0">
+              <a:latin typeface="Times New Roman" panose="02020603050405020304" pitchFamily="18" charset="0"/>
+              <a:ea typeface="宋体" panose="02010600030101010101" pitchFamily="2" charset="-122"/>
+              <a:cs typeface="Times New Roman" panose="02020603050405020304" pitchFamily="18" charset="0"/>
+            </a:endParaRPr>
+          </a:p>
+          <a:p>
+            <a:pPr marL="0" indent="0">
+              <a:buFont typeface="Wingdings" panose="05000000000000000000" charset="0"/>
+              <a:buNone/>
+            </a:pPr>
+            <a:r>
+              <a:rPr lang="zh-CN" altLang="en-US" sz="1200" dirty="0">
+                <a:latin typeface="Times New Roman" panose="02020603050405020304" pitchFamily="18" charset="0"/>
+                <a:ea typeface="宋体" panose="02010600030101010101" pitchFamily="2" charset="-122"/>
+                <a:cs typeface="Times New Roman" panose="02020603050405020304" pitchFamily="18" charset="0"/>
+              </a:rPr>
+              <a:t>分离不同药物抗体比（</a:t>
+            </a:r>
+            <a:r>
+              <a:rPr lang="en-US" altLang="zh-CN" sz="1200" dirty="0">
+                <a:latin typeface="Times New Roman" panose="02020603050405020304" pitchFamily="18" charset="0"/>
+                <a:ea typeface="宋体" panose="02010600030101010101" pitchFamily="2" charset="-122"/>
+                <a:cs typeface="Times New Roman" panose="02020603050405020304" pitchFamily="18" charset="0"/>
+              </a:rPr>
+              <a:t>DAR</a:t>
+            </a:r>
+            <a:r>
+              <a:rPr lang="zh-CN" altLang="en-US" sz="1200" dirty="0">
+                <a:latin typeface="Times New Roman" panose="02020603050405020304" pitchFamily="18" charset="0"/>
+                <a:ea typeface="宋体" panose="02010600030101010101" pitchFamily="2" charset="-122"/>
+                <a:cs typeface="Times New Roman" panose="02020603050405020304" pitchFamily="18" charset="0"/>
+              </a:rPr>
+              <a:t>）的组分：生产得到的</a:t>
+            </a:r>
+            <a:r>
+              <a:rPr lang="en-US" altLang="zh-CN" sz="1200" dirty="0">
+                <a:latin typeface="Times New Roman" panose="02020603050405020304" pitchFamily="18" charset="0"/>
+                <a:ea typeface="宋体" panose="02010600030101010101" pitchFamily="2" charset="-122"/>
+                <a:cs typeface="Times New Roman" panose="02020603050405020304" pitchFamily="18" charset="0"/>
+              </a:rPr>
+              <a:t>ADC</a:t>
+            </a:r>
+            <a:r>
+              <a:rPr lang="zh-CN" altLang="en-US" sz="1200" dirty="0">
+                <a:latin typeface="Times New Roman" panose="02020603050405020304" pitchFamily="18" charset="0"/>
+                <a:ea typeface="宋体" panose="02010600030101010101" pitchFamily="2" charset="-122"/>
+                <a:cs typeface="Times New Roman" panose="02020603050405020304" pitchFamily="18" charset="0"/>
+              </a:rPr>
+              <a:t>通常是包含不同数量药物分子的抗体混合物（例如，</a:t>
+            </a:r>
+            <a:r>
+              <a:rPr lang="en-US" altLang="zh-CN" sz="1200" dirty="0">
+                <a:latin typeface="Times New Roman" panose="02020603050405020304" pitchFamily="18" charset="0"/>
+                <a:ea typeface="宋体" panose="02010600030101010101" pitchFamily="2" charset="-122"/>
+                <a:cs typeface="Times New Roman" panose="02020603050405020304" pitchFamily="18" charset="0"/>
+              </a:rPr>
+              <a:t>DAR=0,2,4,6,8</a:t>
+            </a:r>
+            <a:r>
+              <a:rPr lang="zh-CN" altLang="en-US" sz="1200" dirty="0">
+                <a:latin typeface="Times New Roman" panose="02020603050405020304" pitchFamily="18" charset="0"/>
+                <a:ea typeface="宋体" panose="02010600030101010101" pitchFamily="2" charset="-122"/>
+                <a:cs typeface="Times New Roman" panose="02020603050405020304" pitchFamily="18" charset="0"/>
+              </a:rPr>
+              <a:t>的混合物）。这个</a:t>
+            </a:r>
+            <a:r>
+              <a:rPr lang="en-US" altLang="zh-CN" sz="1200" dirty="0">
+                <a:latin typeface="Times New Roman" panose="02020603050405020304" pitchFamily="18" charset="0"/>
+                <a:ea typeface="宋体" panose="02010600030101010101" pitchFamily="2" charset="-122"/>
+                <a:cs typeface="Times New Roman" panose="02020603050405020304" pitchFamily="18" charset="0"/>
+              </a:rPr>
+              <a:t>DAR</a:t>
+            </a:r>
+            <a:r>
+              <a:rPr lang="zh-CN" altLang="en-US" sz="1200" dirty="0">
+                <a:latin typeface="Times New Roman" panose="02020603050405020304" pitchFamily="18" charset="0"/>
+                <a:ea typeface="宋体" panose="02010600030101010101" pitchFamily="2" charset="-122"/>
+                <a:cs typeface="Times New Roman" panose="02020603050405020304" pitchFamily="18" charset="0"/>
+              </a:rPr>
+              <a:t>值是影响药物疗效和安全性的关键质量属性：</a:t>
+            </a:r>
+            <a:r>
+              <a:rPr lang="en-US" altLang="zh-CN" sz="1200" dirty="0">
+                <a:latin typeface="Times New Roman" panose="02020603050405020304" pitchFamily="18" charset="0"/>
+                <a:ea typeface="宋体" panose="02010600030101010101" pitchFamily="2" charset="-122"/>
+                <a:cs typeface="Times New Roman" panose="02020603050405020304" pitchFamily="18" charset="0"/>
+              </a:rPr>
+              <a:t>DAR</a:t>
+            </a:r>
+            <a:r>
+              <a:rPr lang="zh-CN" altLang="en-US" sz="1200" dirty="0">
+                <a:latin typeface="Times New Roman" panose="02020603050405020304" pitchFamily="18" charset="0"/>
+                <a:ea typeface="宋体" panose="02010600030101010101" pitchFamily="2" charset="-122"/>
+                <a:cs typeface="Times New Roman" panose="02020603050405020304" pitchFamily="18" charset="0"/>
+              </a:rPr>
+              <a:t>过高的组分可能导致聚集和体内清除过快，影响安全性和药效；</a:t>
+            </a:r>
+            <a:r>
+              <a:rPr lang="en-US" altLang="zh-CN" sz="1200" dirty="0">
+                <a:latin typeface="Times New Roman" panose="02020603050405020304" pitchFamily="18" charset="0"/>
+                <a:ea typeface="宋体" panose="02010600030101010101" pitchFamily="2" charset="-122"/>
+                <a:cs typeface="Times New Roman" panose="02020603050405020304" pitchFamily="18" charset="0"/>
+              </a:rPr>
+              <a:t>DAR</a:t>
+            </a:r>
+            <a:r>
+              <a:rPr lang="zh-CN" altLang="en-US" sz="1200" dirty="0">
+                <a:latin typeface="Times New Roman" panose="02020603050405020304" pitchFamily="18" charset="0"/>
+                <a:ea typeface="宋体" panose="02010600030101010101" pitchFamily="2" charset="-122"/>
+                <a:cs typeface="Times New Roman" panose="02020603050405020304" pitchFamily="18" charset="0"/>
+              </a:rPr>
+              <a:t>过低的组分药效不足。</a:t>
+            </a:r>
+          </a:p>
+          <a:p>
+            <a:endParaRPr lang="zh-CN" altLang="en-US" sz="1200" dirty="0">
+              <a:latin typeface="Times New Roman" panose="02020603050405020304" pitchFamily="18" charset="0"/>
+              <a:ea typeface="宋体" panose="02010600030101010101" pitchFamily="2" charset="-122"/>
+              <a:cs typeface="Times New Roman" panose="02020603050405020304" pitchFamily="18" charset="0"/>
+            </a:endParaRPr>
+          </a:p>
+          <a:p>
+            <a:pPr marL="0" indent="0">
+              <a:buFont typeface="Wingdings" panose="05000000000000000000" charset="0"/>
+              <a:buNone/>
+            </a:pPr>
+            <a:r>
+              <a:rPr lang="zh-CN" altLang="en-US" sz="1200" dirty="0">
+                <a:latin typeface="Times New Roman" panose="02020603050405020304" pitchFamily="18" charset="0"/>
+                <a:ea typeface="宋体" panose="02010600030101010101" pitchFamily="2" charset="-122"/>
+                <a:cs typeface="Times New Roman" panose="02020603050405020304" pitchFamily="18" charset="0"/>
+              </a:rPr>
+              <a:t>去除聚集体：在</a:t>
+            </a:r>
+            <a:r>
+              <a:rPr lang="en-US" altLang="zh-CN" sz="1200" dirty="0">
+                <a:latin typeface="Times New Roman" panose="02020603050405020304" pitchFamily="18" charset="0"/>
+                <a:ea typeface="宋体" panose="02010600030101010101" pitchFamily="2" charset="-122"/>
+                <a:cs typeface="Times New Roman" panose="02020603050405020304" pitchFamily="18" charset="0"/>
+              </a:rPr>
+              <a:t>ADC</a:t>
+            </a:r>
+            <a:r>
+              <a:rPr lang="zh-CN" altLang="en-US" sz="1200" dirty="0">
+                <a:latin typeface="Times New Roman" panose="02020603050405020304" pitchFamily="18" charset="0"/>
+                <a:ea typeface="宋体" panose="02010600030101010101" pitchFamily="2" charset="-122"/>
+                <a:cs typeface="Times New Roman" panose="02020603050405020304" pitchFamily="18" charset="0"/>
+              </a:rPr>
+              <a:t>的生产和纯化过程中，蛋白质可能会形成聚集体。这些聚集体是一个主要的制造难题，因为它会促进免疫原性，可能导致严重的不良反应。</a:t>
+            </a:r>
+          </a:p>
+          <a:p>
+            <a:endParaRPr lang="zh-CN" altLang="en-US" sz="1200" dirty="0">
+              <a:latin typeface="Times New Roman" panose="02020603050405020304" pitchFamily="18" charset="0"/>
+              <a:ea typeface="宋体" panose="02010600030101010101" pitchFamily="2" charset="-122"/>
+              <a:cs typeface="Times New Roman" panose="02020603050405020304" pitchFamily="18" charset="0"/>
+            </a:endParaRPr>
+          </a:p>
+          <a:p>
+            <a:pPr marL="0" indent="0">
+              <a:buFont typeface="Wingdings" panose="05000000000000000000" charset="0"/>
+              <a:buNone/>
+            </a:pPr>
+            <a:r>
+              <a:rPr lang="zh-CN" altLang="en-US" sz="1200" dirty="0">
+                <a:latin typeface="Times New Roman" panose="02020603050405020304" pitchFamily="18" charset="0"/>
+                <a:ea typeface="宋体" panose="02010600030101010101" pitchFamily="2" charset="-122"/>
+                <a:cs typeface="Times New Roman" panose="02020603050405020304" pitchFamily="18" charset="0"/>
+              </a:rPr>
+              <a:t>清除游离的药物连接子及相关杂质：</a:t>
+            </a:r>
+            <a:r>
+              <a:rPr lang="en-US" altLang="zh-CN" sz="1200" dirty="0">
+                <a:latin typeface="Times New Roman" panose="02020603050405020304" pitchFamily="18" charset="0"/>
+                <a:ea typeface="宋体" panose="02010600030101010101" pitchFamily="2" charset="-122"/>
+                <a:cs typeface="Times New Roman" panose="02020603050405020304" pitchFamily="18" charset="0"/>
+              </a:rPr>
+              <a:t>ADC</a:t>
+            </a:r>
+            <a:r>
+              <a:rPr lang="zh-CN" altLang="en-US" sz="1200" dirty="0">
+                <a:latin typeface="Times New Roman" panose="02020603050405020304" pitchFamily="18" charset="0"/>
+                <a:ea typeface="宋体" panose="02010600030101010101" pitchFamily="2" charset="-122"/>
+                <a:cs typeface="Times New Roman" panose="02020603050405020304" pitchFamily="18" charset="0"/>
+              </a:rPr>
+              <a:t>所携带的小分子</a:t>
+            </a:r>
+            <a:r>
+              <a:rPr lang="en-US" altLang="zh-CN" sz="1200" dirty="0">
+                <a:latin typeface="Times New Roman" panose="02020603050405020304" pitchFamily="18" charset="0"/>
+                <a:ea typeface="宋体" panose="02010600030101010101" pitchFamily="2" charset="-122"/>
+                <a:cs typeface="Times New Roman" panose="02020603050405020304" pitchFamily="18" charset="0"/>
+              </a:rPr>
+              <a:t>“</a:t>
+            </a:r>
+            <a:r>
+              <a:rPr lang="zh-CN" altLang="en-US" sz="1200" dirty="0">
+                <a:latin typeface="Times New Roman" panose="02020603050405020304" pitchFamily="18" charset="0"/>
+                <a:ea typeface="宋体" panose="02010600030101010101" pitchFamily="2" charset="-122"/>
+                <a:cs typeface="Times New Roman" panose="02020603050405020304" pitchFamily="18" charset="0"/>
+              </a:rPr>
+              <a:t>有效载荷</a:t>
+            </a:r>
+            <a:r>
+              <a:rPr lang="en-US" altLang="zh-CN" sz="1200" dirty="0">
+                <a:latin typeface="Times New Roman" panose="02020603050405020304" pitchFamily="18" charset="0"/>
+                <a:ea typeface="宋体" panose="02010600030101010101" pitchFamily="2" charset="-122"/>
+                <a:cs typeface="Times New Roman" panose="02020603050405020304" pitchFamily="18" charset="0"/>
+              </a:rPr>
+              <a:t>”</a:t>
+            </a:r>
+            <a:r>
+              <a:rPr lang="zh-CN" altLang="en-US" sz="1200" dirty="0">
+                <a:latin typeface="Times New Roman" panose="02020603050405020304" pitchFamily="18" charset="0"/>
+                <a:ea typeface="宋体" panose="02010600030101010101" pitchFamily="2" charset="-122"/>
+                <a:cs typeface="Times New Roman" panose="02020603050405020304" pitchFamily="18" charset="0"/>
+              </a:rPr>
+              <a:t>（</a:t>
+            </a:r>
+            <a:r>
+              <a:rPr lang="en-US" altLang="zh-CN" sz="1200" dirty="0">
+                <a:latin typeface="Times New Roman" panose="02020603050405020304" pitchFamily="18" charset="0"/>
+                <a:ea typeface="宋体" panose="02010600030101010101" pitchFamily="2" charset="-122"/>
+                <a:cs typeface="Times New Roman" panose="02020603050405020304" pitchFamily="18" charset="0"/>
+              </a:rPr>
+              <a:t>payload</a:t>
+            </a:r>
+            <a:r>
+              <a:rPr lang="zh-CN" altLang="en-US" sz="1200" dirty="0">
+                <a:latin typeface="Times New Roman" panose="02020603050405020304" pitchFamily="18" charset="0"/>
+                <a:ea typeface="宋体" panose="02010600030101010101" pitchFamily="2" charset="-122"/>
+                <a:cs typeface="Times New Roman" panose="02020603050405020304" pitchFamily="18" charset="0"/>
+              </a:rPr>
+              <a:t>）通常具有极高的细胞毒性。因此，在偶联反应后，任何残留的、未结合到抗体上的游离药物连接子都必须被彻底清除，以确保最终药品的安全性。</a:t>
+            </a:r>
+          </a:p>
+          <a:p>
+            <a:endParaRPr lang="zh-CN" altLang="en-US" dirty="0"/>
+          </a:p>
+        </p:txBody>
+      </p:sp>
+      <p:sp>
+        <p:nvSpPr>
+          <p:cNvPr id="4" name="灯片编号占位符 3"/>
+          <p:cNvSpPr>
+            <a:spLocks noGrp="1"/>
+          </p:cNvSpPr>
+          <p:nvPr>
+            <p:ph type="sldNum" sz="quarter" idx="5"/>
+          </p:nvPr>
+        </p:nvSpPr>
+        <p:spPr/>
+        <p:txBody>
+          <a:bodyPr/>
+          <a:lstStyle/>
+          <a:p>
+            <a:fld id="{337F53EF-5364-44E3-BFA2-84231755F7E3}" type="slidenum">
+              <a:rPr lang="zh-CN" altLang="en-US" smtClean="0"/>
+              <a:t>8</a:t>
+            </a:fld>
+            <a:endParaRPr lang="zh-CN" altLang="en-US"/>
+          </a:p>
+        </p:txBody>
+      </p:sp>
+    </p:spTree>
+    <p:extLst>
+      <p:ext uri="{BB962C8B-B14F-4D97-AF65-F5344CB8AC3E}">
+        <p14:creationId xmlns:p14="http://schemas.microsoft.com/office/powerpoint/2010/main" val="3565999757"/>
       </p:ext>
     </p:extLst>
   </p:cSld>
@@ -16577,7 +17369,7 @@
           <p:nvPr/>
         </p:nvPicPr>
         <p:blipFill>
-          <a:blip r:embed="rId2">
+          <a:blip r:embed="rId3">
             <a:extLst>
               <a:ext uri="{28A0092B-C50C-407E-A947-70E740481C1C}">
                 <a14:useLocalDpi xmlns:a14="http://schemas.microsoft.com/office/drawing/2010/main" val="0"/>
@@ -16649,7 +17441,7 @@
           <p:nvPr/>
         </p:nvPicPr>
         <p:blipFill>
-          <a:blip r:embed="rId3"/>
+          <a:blip r:embed="rId4"/>
           <a:srcRect l="28039" t="32398" r="29243" b="22787"/>
           <a:stretch>
             <a:fillRect/>
@@ -16998,7 +17790,7 @@
           <p:nvPr/>
         </p:nvPicPr>
         <p:blipFill>
-          <a:blip r:embed="rId2">
+          <a:blip r:embed="rId3">
             <a:extLst>
               <a:ext uri="{28A0092B-C50C-407E-A947-70E740481C1C}">
                 <a14:useLocalDpi xmlns:a14="http://schemas.microsoft.com/office/drawing/2010/main" val="0"/>
@@ -17070,14 +17862,14 @@
           <p:nvPr/>
         </p:nvPicPr>
         <p:blipFill>
-          <a:blip r:embed="rId3"/>
+          <a:blip r:embed="rId4"/>
           <a:stretch>
             <a:fillRect/>
           </a:stretch>
         </p:blipFill>
         <p:spPr>
           <a:xfrm>
-            <a:off x="143510" y="1368425"/>
+            <a:off x="1983740" y="1662065"/>
             <a:ext cx="8224520" cy="4781550"/>
           </a:xfrm>
           <a:prstGeom prst="rect">
@@ -17087,14 +17879,20 @@
       </p:pic>
       <p:sp>
         <p:nvSpPr>
-          <p:cNvPr id="13" name="文本框 12"/>
+          <p:cNvPr id="4" name="文本框 3">
+            <a:extLst>
+              <a:ext uri="{FF2B5EF4-FFF2-40B4-BE49-F238E27FC236}">
+                <a16:creationId xmlns:a16="http://schemas.microsoft.com/office/drawing/2014/main" id="{348E1FE8-F98D-4769-87D1-D67B86337EAB}"/>
+              </a:ext>
+            </a:extLst>
+          </p:cNvPr>
           <p:cNvSpPr txBox="1"/>
           <p:nvPr/>
         </p:nvSpPr>
         <p:spPr>
           <a:xfrm>
-            <a:off x="8174355" y="1576070"/>
-            <a:ext cx="3725545" cy="4619625"/>
+            <a:off x="720436" y="995805"/>
+            <a:ext cx="2990951" cy="461665"/>
           </a:xfrm>
           <a:prstGeom prst="rect">
             <a:avLst/>
@@ -17103,231 +17901,23 @@
         </p:spPr>
         <p:txBody>
           <a:bodyPr wrap="square" rtlCol="0">
-            <a:noAutofit/>
+            <a:spAutoFit/>
           </a:bodyPr>
           <a:lstStyle/>
           <a:p>
-            <a:pPr marL="342900" indent="-342900">
-              <a:buFont typeface="Wingdings" panose="05000000000000000000" charset="0"/>
-              <a:buChar char="Ø"/>
-            </a:pPr>
-            <a:r>
-              <a:rPr lang="en-US" altLang="zh-CN" sz="2000">
-                <a:latin typeface="Times New Roman" panose="02020603050405020304" pitchFamily="18" charset="0"/>
-                <a:ea typeface="宋体" panose="02010600030101010101" pitchFamily="2" charset="-122"/>
-                <a:cs typeface="Times New Roman" panose="02020603050405020304" pitchFamily="18" charset="0"/>
-              </a:rPr>
-              <a:t>mAb</a:t>
-            </a:r>
-            <a:r>
-              <a:rPr lang="zh-CN" altLang="en-US" sz="2000">
-                <a:latin typeface="Times New Roman" panose="02020603050405020304" pitchFamily="18" charset="0"/>
-                <a:ea typeface="宋体" panose="02010600030101010101" pitchFamily="2" charset="-122"/>
-                <a:cs typeface="Times New Roman" panose="02020603050405020304" pitchFamily="18" charset="0"/>
-              </a:rPr>
-              <a:t>先经</a:t>
-            </a:r>
-            <a:r>
-              <a:rPr lang="en-US" altLang="zh-CN" sz="2000">
-                <a:latin typeface="Times New Roman" panose="02020603050405020304" pitchFamily="18" charset="0"/>
-                <a:ea typeface="宋体" panose="02010600030101010101" pitchFamily="2" charset="-122"/>
-                <a:cs typeface="Times New Roman" panose="02020603050405020304" pitchFamily="18" charset="0"/>
-              </a:rPr>
-              <a:t>TFF</a:t>
-            </a:r>
-            <a:r>
-              <a:rPr lang="zh-CN" altLang="en-US" sz="2000">
-                <a:latin typeface="Times New Roman" panose="02020603050405020304" pitchFamily="18" charset="0"/>
-                <a:ea typeface="宋体" panose="02010600030101010101" pitchFamily="2" charset="-122"/>
-                <a:cs typeface="Times New Roman" panose="02020603050405020304" pitchFamily="18" charset="0"/>
-              </a:rPr>
-              <a:t>进行缓冲液置换或稀释，将体系调整为适配后续反应的状态。</a:t>
-            </a:r>
-          </a:p>
-          <a:p>
-            <a:pPr marL="342900" indent="-342900">
-              <a:buFont typeface="Wingdings" panose="05000000000000000000" charset="0"/>
-              <a:buChar char="Ø"/>
-            </a:pPr>
-            <a:r>
-              <a:rPr lang="zh-CN" altLang="en-US" sz="2000">
-                <a:latin typeface="Times New Roman" panose="02020603050405020304" pitchFamily="18" charset="0"/>
-                <a:ea typeface="宋体" panose="02010600030101010101" pitchFamily="2" charset="-122"/>
-                <a:cs typeface="Times New Roman" panose="02020603050405020304" pitchFamily="18" charset="0"/>
-              </a:rPr>
-              <a:t>对</a:t>
-            </a:r>
-            <a:r>
-              <a:rPr lang="en-US" altLang="zh-CN" sz="2000">
-                <a:latin typeface="Times New Roman" panose="02020603050405020304" pitchFamily="18" charset="0"/>
-                <a:ea typeface="宋体" panose="02010600030101010101" pitchFamily="2" charset="-122"/>
-                <a:cs typeface="Times New Roman" panose="02020603050405020304" pitchFamily="18" charset="0"/>
-              </a:rPr>
-              <a:t>mAb</a:t>
-            </a:r>
-            <a:r>
-              <a:rPr lang="zh-CN" altLang="en-US" sz="2000">
-                <a:latin typeface="Times New Roman" panose="02020603050405020304" pitchFamily="18" charset="0"/>
-                <a:ea typeface="宋体" panose="02010600030101010101" pitchFamily="2" charset="-122"/>
-                <a:cs typeface="Times New Roman" panose="02020603050405020304" pitchFamily="18" charset="0"/>
-              </a:rPr>
-              <a:t>进行修饰（如</a:t>
-            </a:r>
-            <a:r>
-              <a:rPr lang="en-US" altLang="zh-CN" sz="2000">
-                <a:latin typeface="Times New Roman" panose="02020603050405020304" pitchFamily="18" charset="0"/>
-                <a:ea typeface="宋体" panose="02010600030101010101" pitchFamily="2" charset="-122"/>
-                <a:cs typeface="Times New Roman" panose="02020603050405020304" pitchFamily="18" charset="0"/>
-              </a:rPr>
-              <a:t>TCEP</a:t>
-            </a:r>
-            <a:r>
-              <a:rPr lang="zh-CN" altLang="en-US" sz="2000">
-                <a:latin typeface="Times New Roman" panose="02020603050405020304" pitchFamily="18" charset="0"/>
-                <a:ea typeface="宋体" panose="02010600030101010101" pitchFamily="2" charset="-122"/>
-                <a:cs typeface="Times New Roman" panose="02020603050405020304" pitchFamily="18" charset="0"/>
-              </a:rPr>
-              <a:t>还原）得到抗体中间体，与细胞毒性载荷偶联后生成粗制</a:t>
-            </a:r>
-            <a:r>
-              <a:rPr lang="en-US" altLang="zh-CN" sz="2000">
-                <a:latin typeface="Times New Roman" panose="02020603050405020304" pitchFamily="18" charset="0"/>
-                <a:ea typeface="宋体" panose="02010600030101010101" pitchFamily="2" charset="-122"/>
-                <a:cs typeface="Times New Roman" panose="02020603050405020304" pitchFamily="18" charset="0"/>
+            <a:r>
+              <a:rPr lang="en-US" altLang="zh-CN" sz="2400" b="1" dirty="0">
+                <a:latin typeface="宋体" panose="02010600030101010101" pitchFamily="2" charset="-122"/>
+                <a:ea typeface="宋体" panose="02010600030101010101" pitchFamily="2" charset="-122"/>
               </a:rPr>
               <a:t>ADC</a:t>
             </a:r>
             <a:r>
-              <a:rPr lang="zh-CN" altLang="en-US" sz="2000">
-                <a:latin typeface="Times New Roman" panose="02020603050405020304" pitchFamily="18" charset="0"/>
-                <a:ea typeface="宋体" panose="02010600030101010101" pitchFamily="2" charset="-122"/>
-                <a:cs typeface="Times New Roman" panose="02020603050405020304" pitchFamily="18" charset="0"/>
-              </a:rPr>
-              <a:t>。</a:t>
-            </a:r>
-          </a:p>
-          <a:p>
-            <a:pPr marL="342900" indent="-342900">
-              <a:buFont typeface="Wingdings" panose="05000000000000000000" charset="0"/>
-              <a:buChar char="Ø"/>
-            </a:pPr>
-            <a:r>
-              <a:rPr lang="zh-CN" altLang="en-US" sz="2000">
-                <a:latin typeface="Times New Roman" panose="02020603050405020304" pitchFamily="18" charset="0"/>
-                <a:ea typeface="宋体" panose="02010600030101010101" pitchFamily="2" charset="-122"/>
-                <a:cs typeface="Times New Roman" panose="02020603050405020304" pitchFamily="18" charset="0"/>
-              </a:rPr>
-              <a:t>粗制</a:t>
-            </a:r>
-            <a:r>
-              <a:rPr lang="en-US" altLang="zh-CN" sz="2000">
-                <a:latin typeface="Times New Roman" panose="02020603050405020304" pitchFamily="18" charset="0"/>
-                <a:ea typeface="宋体" panose="02010600030101010101" pitchFamily="2" charset="-122"/>
-                <a:cs typeface="Times New Roman" panose="02020603050405020304" pitchFamily="18" charset="0"/>
-              </a:rPr>
-              <a:t>ADC</a:t>
-            </a:r>
-            <a:r>
-              <a:rPr lang="zh-CN" altLang="en-US" sz="2000">
-                <a:latin typeface="Times New Roman" panose="02020603050405020304" pitchFamily="18" charset="0"/>
-                <a:ea typeface="宋体" panose="02010600030101010101" pitchFamily="2" charset="-122"/>
-                <a:cs typeface="Times New Roman" panose="02020603050405020304" pitchFamily="18" charset="0"/>
-              </a:rPr>
-              <a:t>可通过</a:t>
-            </a:r>
-            <a:r>
-              <a:rPr lang="en-US" altLang="zh-CN" sz="2000">
-                <a:latin typeface="Times New Roman" panose="02020603050405020304" pitchFamily="18" charset="0"/>
-                <a:ea typeface="宋体" panose="02010600030101010101" pitchFamily="2" charset="-122"/>
-                <a:cs typeface="Times New Roman" panose="02020603050405020304" pitchFamily="18" charset="0"/>
-              </a:rPr>
-              <a:t>TFF</a:t>
-            </a:r>
-            <a:r>
-              <a:rPr lang="zh-CN" altLang="en-US" sz="2000">
-                <a:latin typeface="Times New Roman" panose="02020603050405020304" pitchFamily="18" charset="0"/>
-                <a:ea typeface="宋体" panose="02010600030101010101" pitchFamily="2" charset="-122"/>
-                <a:cs typeface="Times New Roman" panose="02020603050405020304" pitchFamily="18" charset="0"/>
-              </a:rPr>
-              <a:t>直接纯化，或经色谱（如</a:t>
-            </a:r>
-            <a:r>
-              <a:rPr lang="en-US" altLang="zh-CN" sz="2000">
-                <a:latin typeface="Times New Roman" panose="02020603050405020304" pitchFamily="18" charset="0"/>
-                <a:ea typeface="宋体" panose="02010600030101010101" pitchFamily="2" charset="-122"/>
-                <a:cs typeface="Times New Roman" panose="02020603050405020304" pitchFamily="18" charset="0"/>
-              </a:rPr>
-              <a:t>SEC</a:t>
-            </a:r>
-            <a:r>
-              <a:rPr lang="zh-CN" altLang="en-US" sz="2000">
-                <a:latin typeface="Times New Roman" panose="02020603050405020304" pitchFamily="18" charset="0"/>
-                <a:ea typeface="宋体" panose="02010600030101010101" pitchFamily="2" charset="-122"/>
-                <a:cs typeface="Times New Roman" panose="02020603050405020304" pitchFamily="18" charset="0"/>
-              </a:rPr>
-              <a:t>、</a:t>
-            </a:r>
-            <a:r>
-              <a:rPr lang="en-US" altLang="zh-CN" sz="2000">
-                <a:latin typeface="Times New Roman" panose="02020603050405020304" pitchFamily="18" charset="0"/>
-                <a:ea typeface="宋体" panose="02010600030101010101" pitchFamily="2" charset="-122"/>
-                <a:cs typeface="Times New Roman" panose="02020603050405020304" pitchFamily="18" charset="0"/>
-              </a:rPr>
-              <a:t>HIC</a:t>
-            </a:r>
-            <a:r>
-              <a:rPr lang="zh-CN" altLang="en-US" sz="2000">
-                <a:latin typeface="Times New Roman" panose="02020603050405020304" pitchFamily="18" charset="0"/>
-                <a:ea typeface="宋体" panose="02010600030101010101" pitchFamily="2" charset="-122"/>
-                <a:cs typeface="Times New Roman" panose="02020603050405020304" pitchFamily="18" charset="0"/>
-              </a:rPr>
-              <a:t>膜色谱）处理纯化。</a:t>
-            </a:r>
-          </a:p>
-          <a:p>
-            <a:pPr marL="342900" indent="-342900">
-              <a:buFont typeface="Wingdings" panose="05000000000000000000" charset="0"/>
-              <a:buChar char="Ø"/>
-            </a:pPr>
-            <a:r>
-              <a:rPr lang="zh-CN" altLang="en-US" sz="2000">
-                <a:latin typeface="Times New Roman" panose="02020603050405020304" pitchFamily="18" charset="0"/>
-                <a:ea typeface="宋体" panose="02010600030101010101" pitchFamily="2" charset="-122"/>
-                <a:cs typeface="Times New Roman" panose="02020603050405020304" pitchFamily="18" charset="0"/>
-              </a:rPr>
-              <a:t>最终再经</a:t>
-            </a:r>
-            <a:r>
-              <a:rPr lang="en-US" altLang="zh-CN" sz="2000">
-                <a:latin typeface="Times New Roman" panose="02020603050405020304" pitchFamily="18" charset="0"/>
-                <a:ea typeface="宋体" panose="02010600030101010101" pitchFamily="2" charset="-122"/>
-                <a:cs typeface="Times New Roman" panose="02020603050405020304" pitchFamily="18" charset="0"/>
-              </a:rPr>
-              <a:t>TFF</a:t>
-            </a:r>
-            <a:r>
-              <a:rPr lang="zh-CN" altLang="en-US" sz="2000">
-                <a:latin typeface="Times New Roman" panose="02020603050405020304" pitchFamily="18" charset="0"/>
-                <a:ea typeface="宋体" panose="02010600030101010101" pitchFamily="2" charset="-122"/>
-                <a:cs typeface="Times New Roman" panose="02020603050405020304" pitchFamily="18" charset="0"/>
-              </a:rPr>
-              <a:t>完成缓冲液置换与制剂调配，得到成品</a:t>
-            </a:r>
-            <a:r>
-              <a:rPr lang="en-US" altLang="zh-CN" sz="2000">
-                <a:latin typeface="Times New Roman" panose="02020603050405020304" pitchFamily="18" charset="0"/>
-                <a:ea typeface="宋体" panose="02010600030101010101" pitchFamily="2" charset="-122"/>
-                <a:cs typeface="Times New Roman" panose="02020603050405020304" pitchFamily="18" charset="0"/>
-              </a:rPr>
-              <a:t>ADC</a:t>
-            </a:r>
-            <a:r>
-              <a:rPr lang="zh-CN" altLang="en-US" sz="2000">
-                <a:latin typeface="Times New Roman" panose="02020603050405020304" pitchFamily="18" charset="0"/>
-                <a:ea typeface="宋体" panose="02010600030101010101" pitchFamily="2" charset="-122"/>
-                <a:cs typeface="Times New Roman" panose="02020603050405020304" pitchFamily="18" charset="0"/>
-              </a:rPr>
-              <a:t>。</a:t>
+              <a:rPr lang="zh-CN" altLang="en-US" sz="2400" b="1" dirty="0">
+                <a:latin typeface="宋体" panose="02010600030101010101" pitchFamily="2" charset="-122"/>
+                <a:ea typeface="宋体" panose="02010600030101010101" pitchFamily="2" charset="-122"/>
+              </a:rPr>
+              <a:t>的合成纯化流程</a:t>
             </a:r>
           </a:p>
         </p:txBody>
@@ -17520,7 +18110,7 @@
           <p:nvPr/>
         </p:nvPicPr>
         <p:blipFill>
-          <a:blip r:embed="rId2">
+          <a:blip r:embed="rId3">
             <a:extLst>
               <a:ext uri="{28A0092B-C50C-407E-A947-70E740481C1C}">
                 <a14:useLocalDpi xmlns:a14="http://schemas.microsoft.com/office/drawing/2010/main" val="0"/>
@@ -17591,8 +18181,8 @@
         </p:nvSpPr>
         <p:spPr>
           <a:xfrm>
-            <a:off x="372745" y="1409065"/>
-            <a:ext cx="11447145" cy="4500880"/>
+            <a:off x="372428" y="1108364"/>
+            <a:ext cx="2258478" cy="332570"/>
           </a:xfrm>
           <a:prstGeom prst="rect">
             <a:avLst/>
@@ -17606,7 +18196,7 @@
           <a:lstStyle/>
           <a:p>
             <a:r>
-              <a:rPr lang="zh-CN" altLang="en-US" sz="2000" b="1">
+              <a:rPr lang="zh-CN" altLang="en-US" sz="2000" b="1" dirty="0">
                 <a:latin typeface="Times New Roman" panose="02020603050405020304" pitchFamily="18" charset="0"/>
                 <a:ea typeface="宋体" panose="02010600030101010101" pitchFamily="2" charset="-122"/>
                 <a:cs typeface="Times New Roman" panose="02020603050405020304" pitchFamily="18" charset="0"/>
@@ -17614,260 +18204,277 @@
               <a:t>分离需解决的问题</a:t>
             </a:r>
           </a:p>
-          <a:p>
-            <a:endParaRPr lang="zh-CN" altLang="en-US" sz="2000" b="1">
-              <a:latin typeface="Times New Roman" panose="02020603050405020304" pitchFamily="18" charset="0"/>
+        </p:txBody>
+      </p:sp>
+      <p:sp>
+        <p:nvSpPr>
+          <p:cNvPr id="11" name="文本框 10">
+            <a:extLst>
+              <a:ext uri="{FF2B5EF4-FFF2-40B4-BE49-F238E27FC236}">
+                <a16:creationId xmlns:a16="http://schemas.microsoft.com/office/drawing/2014/main" id="{FA929A82-9340-4F09-868B-5D41090841F7}"/>
+              </a:ext>
+            </a:extLst>
+          </p:cNvPr>
+          <p:cNvSpPr txBox="1"/>
+          <p:nvPr/>
+        </p:nvSpPr>
+        <p:spPr>
+          <a:xfrm>
+            <a:off x="526473" y="1948934"/>
+            <a:ext cx="2258478" cy="1748590"/>
+          </a:xfrm>
+          <a:prstGeom prst="rect">
+            <a:avLst/>
+          </a:prstGeom>
+          <a:noFill/>
+        </p:spPr>
+        <p:txBody>
+          <a:bodyPr wrap="square" rtlCol="0">
+            <a:spAutoFit/>
+          </a:bodyPr>
+          <a:lstStyle/>
+          <a:p>
+            <a:endParaRPr lang="zh-CN" altLang="en-US" dirty="0"/>
+          </a:p>
+        </p:txBody>
+      </p:sp>
+      <p:pic>
+        <p:nvPicPr>
+          <p:cNvPr id="15" name="图片 14">
+            <a:extLst>
+              <a:ext uri="{FF2B5EF4-FFF2-40B4-BE49-F238E27FC236}">
+                <a16:creationId xmlns:a16="http://schemas.microsoft.com/office/drawing/2014/main" id="{0D0CA946-ADD5-4665-9517-87F935765B14}"/>
+              </a:ext>
+            </a:extLst>
+          </p:cNvPr>
+          <p:cNvPicPr>
+            <a:picLocks noChangeAspect="1"/>
+          </p:cNvPicPr>
+          <p:nvPr/>
+        </p:nvPicPr>
+        <p:blipFill>
+          <a:blip r:embed="rId4"/>
+          <a:stretch>
+            <a:fillRect/>
+          </a:stretch>
+        </p:blipFill>
+        <p:spPr>
+          <a:xfrm>
+            <a:off x="526473" y="1631561"/>
+            <a:ext cx="3548792" cy="2383336"/>
+          </a:xfrm>
+          <a:prstGeom prst="rect">
+            <a:avLst/>
+          </a:prstGeom>
+        </p:spPr>
+      </p:pic>
+      <p:pic>
+        <p:nvPicPr>
+          <p:cNvPr id="17" name="图片 16">
+            <a:extLst>
+              <a:ext uri="{FF2B5EF4-FFF2-40B4-BE49-F238E27FC236}">
+                <a16:creationId xmlns:a16="http://schemas.microsoft.com/office/drawing/2014/main" id="{D925B0C5-AF6E-4435-8BFD-1C4D186F4E33}"/>
+              </a:ext>
+            </a:extLst>
+          </p:cNvPr>
+          <p:cNvPicPr>
+            <a:picLocks/>
+          </p:cNvPicPr>
+          <p:nvPr/>
+        </p:nvPicPr>
+        <p:blipFill>
+          <a:blip r:embed="rId5"/>
+          <a:stretch>
+            <a:fillRect/>
+          </a:stretch>
+        </p:blipFill>
+        <p:spPr>
+          <a:xfrm>
+            <a:off x="4321200" y="4014897"/>
+            <a:ext cx="3549600" cy="2383200"/>
+          </a:xfrm>
+          <a:prstGeom prst="rect">
+            <a:avLst/>
+          </a:prstGeom>
+        </p:spPr>
+      </p:pic>
+      <p:sp>
+        <p:nvSpPr>
+          <p:cNvPr id="19" name="文本框 18">
+            <a:extLst>
+              <a:ext uri="{FF2B5EF4-FFF2-40B4-BE49-F238E27FC236}">
+                <a16:creationId xmlns:a16="http://schemas.microsoft.com/office/drawing/2014/main" id="{0BB665CF-11D0-4EE3-B2BD-6CF04C6CC643}"/>
+              </a:ext>
+            </a:extLst>
+          </p:cNvPr>
+          <p:cNvSpPr txBox="1"/>
+          <p:nvPr/>
+        </p:nvSpPr>
+        <p:spPr>
+          <a:xfrm>
+            <a:off x="525666" y="4437529"/>
+            <a:ext cx="3549599" cy="1261884"/>
+          </a:xfrm>
+          <a:prstGeom prst="rect">
+            <a:avLst/>
+          </a:prstGeom>
+          <a:noFill/>
+        </p:spPr>
+        <p:txBody>
+          <a:bodyPr wrap="square" rtlCol="0">
+            <a:spAutoFit/>
+          </a:bodyPr>
+          <a:lstStyle/>
+          <a:p>
+            <a:pPr>
+              <a:lnSpc>
+                <a:spcPct val="150000"/>
+              </a:lnSpc>
+            </a:pPr>
+            <a:r>
+              <a:rPr lang="zh-CN" altLang="en-US" sz="2400" b="1" dirty="0"/>
+              <a:t>问题一：</a:t>
+            </a:r>
+            <a:endParaRPr lang="en-US" altLang="zh-CN" sz="2400" b="1" dirty="0"/>
+          </a:p>
+          <a:p>
+            <a:r>
+              <a:rPr lang="zh-CN" altLang="en-US" sz="2000" dirty="0">
+                <a:latin typeface="Times New Roman" panose="02020603050405020304" pitchFamily="18" charset="0"/>
+                <a:ea typeface="宋体" panose="02010600030101010101" pitchFamily="2" charset="-122"/>
+                <a:cs typeface="Times New Roman" panose="02020603050405020304" pitchFamily="18" charset="0"/>
+              </a:rPr>
+              <a:t>分离不同药物抗体比（</a:t>
+            </a:r>
+            <a:r>
+              <a:rPr lang="en-US" altLang="zh-CN" sz="2000" dirty="0">
+                <a:latin typeface="Times New Roman" panose="02020603050405020304" pitchFamily="18" charset="0"/>
+                <a:ea typeface="宋体" panose="02010600030101010101" pitchFamily="2" charset="-122"/>
+                <a:cs typeface="Times New Roman" panose="02020603050405020304" pitchFamily="18" charset="0"/>
+              </a:rPr>
+              <a:t>DAR</a:t>
+            </a:r>
+            <a:r>
+              <a:rPr lang="zh-CN" altLang="en-US" sz="2000" dirty="0">
+                <a:latin typeface="Times New Roman" panose="02020603050405020304" pitchFamily="18" charset="0"/>
+                <a:ea typeface="宋体" panose="02010600030101010101" pitchFamily="2" charset="-122"/>
+                <a:cs typeface="Times New Roman" panose="02020603050405020304" pitchFamily="18" charset="0"/>
+              </a:rPr>
+              <a:t>）的组分</a:t>
+            </a:r>
+            <a:endParaRPr lang="zh-CN" altLang="en-US" sz="2000" dirty="0"/>
+          </a:p>
+        </p:txBody>
+      </p:sp>
+      <p:sp>
+        <p:nvSpPr>
+          <p:cNvPr id="20" name="文本框 19">
+            <a:extLst>
+              <a:ext uri="{FF2B5EF4-FFF2-40B4-BE49-F238E27FC236}">
+                <a16:creationId xmlns:a16="http://schemas.microsoft.com/office/drawing/2014/main" id="{5F353A0F-D98E-4A01-8506-5FBE095562B0}"/>
+              </a:ext>
+            </a:extLst>
+          </p:cNvPr>
+          <p:cNvSpPr txBox="1"/>
+          <p:nvPr/>
+        </p:nvSpPr>
+        <p:spPr>
+          <a:xfrm>
+            <a:off x="4321201" y="2043953"/>
+            <a:ext cx="3549600" cy="1231106"/>
+          </a:xfrm>
+          <a:prstGeom prst="rect">
+            <a:avLst/>
+          </a:prstGeom>
+          <a:noFill/>
+        </p:spPr>
+        <p:txBody>
+          <a:bodyPr wrap="square" rtlCol="0">
+            <a:spAutoFit/>
+          </a:bodyPr>
+          <a:lstStyle/>
+          <a:p>
+            <a:pPr>
+              <a:lnSpc>
+                <a:spcPct val="150000"/>
+              </a:lnSpc>
+            </a:pPr>
+            <a:r>
+              <a:rPr lang="zh-CN" altLang="en-US" sz="2400" b="1" dirty="0"/>
+              <a:t>问题二：</a:t>
+            </a:r>
+            <a:endParaRPr lang="en-US" altLang="zh-CN" sz="2400" b="1" dirty="0"/>
+          </a:p>
+          <a:p>
+            <a:r>
+              <a:rPr lang="zh-CN" altLang="en-US" sz="2000" dirty="0">
+                <a:latin typeface="宋体" panose="02010600030101010101" pitchFamily="2" charset="-122"/>
+                <a:ea typeface="宋体" panose="02010600030101010101" pitchFamily="2" charset="-122"/>
+              </a:rPr>
+              <a:t>去除形成的蛋白聚集体</a:t>
+            </a:r>
+            <a:endParaRPr lang="en-US" altLang="zh-CN" sz="2000" dirty="0">
+              <a:latin typeface="宋体" panose="02010600030101010101" pitchFamily="2" charset="-122"/>
               <a:ea typeface="宋体" panose="02010600030101010101" pitchFamily="2" charset="-122"/>
-              <a:cs typeface="Times New Roman" panose="02020603050405020304" pitchFamily="18" charset="0"/>
             </a:endParaRPr>
           </a:p>
           <a:p>
-            <a:pPr marL="342900" indent="-342900">
-              <a:buFont typeface="Wingdings" panose="05000000000000000000" charset="0"/>
-              <a:buChar char="Ø"/>
+            <a:endParaRPr lang="zh-CN" altLang="en-US" dirty="0"/>
+          </a:p>
+        </p:txBody>
+      </p:sp>
+      <p:sp>
+        <p:nvSpPr>
+          <p:cNvPr id="21" name="文本框 20">
+            <a:extLst>
+              <a:ext uri="{FF2B5EF4-FFF2-40B4-BE49-F238E27FC236}">
+                <a16:creationId xmlns:a16="http://schemas.microsoft.com/office/drawing/2014/main" id="{53BA0432-E243-4D72-B266-8436C571F3DA}"/>
+              </a:ext>
+            </a:extLst>
+          </p:cNvPr>
+          <p:cNvSpPr txBox="1"/>
+          <p:nvPr/>
+        </p:nvSpPr>
+        <p:spPr>
+          <a:xfrm>
+            <a:off x="8368146" y="4437529"/>
+            <a:ext cx="3398030" cy="1538883"/>
+          </a:xfrm>
+          <a:prstGeom prst="rect">
+            <a:avLst/>
+          </a:prstGeom>
+          <a:noFill/>
+        </p:spPr>
+        <p:txBody>
+          <a:bodyPr wrap="square" rtlCol="0">
+            <a:spAutoFit/>
+          </a:bodyPr>
+          <a:lstStyle/>
+          <a:p>
+            <a:pPr>
+              <a:lnSpc>
+                <a:spcPct val="150000"/>
+              </a:lnSpc>
             </a:pPr>
             <a:r>
-              <a:rPr lang="zh-CN" altLang="en-US" sz="2000">
-                <a:latin typeface="Times New Roman" panose="02020603050405020304" pitchFamily="18" charset="0"/>
-                <a:ea typeface="宋体" panose="02010600030101010101" pitchFamily="2" charset="-122"/>
-                <a:cs typeface="Times New Roman" panose="02020603050405020304" pitchFamily="18" charset="0"/>
-              </a:rPr>
-              <a:t>分离不同药物抗体比（</a:t>
-            </a:r>
-            <a:r>
-              <a:rPr lang="en-US" altLang="zh-CN" sz="2000">
-                <a:latin typeface="Times New Roman" panose="02020603050405020304" pitchFamily="18" charset="0"/>
-                <a:ea typeface="宋体" panose="02010600030101010101" pitchFamily="2" charset="-122"/>
-                <a:cs typeface="Times New Roman" panose="02020603050405020304" pitchFamily="18" charset="0"/>
-              </a:rPr>
-              <a:t>DAR</a:t>
-            </a:r>
-            <a:r>
-              <a:rPr lang="zh-CN" altLang="en-US" sz="2000">
-                <a:latin typeface="Times New Roman" panose="02020603050405020304" pitchFamily="18" charset="0"/>
-                <a:ea typeface="宋体" panose="02010600030101010101" pitchFamily="2" charset="-122"/>
-                <a:cs typeface="Times New Roman" panose="02020603050405020304" pitchFamily="18" charset="0"/>
-              </a:rPr>
-              <a:t>，</a:t>
-            </a:r>
-            <a:r>
-              <a:rPr lang="en-US" altLang="zh-CN" sz="2000">
-                <a:latin typeface="Times New Roman" panose="02020603050405020304" pitchFamily="18" charset="0"/>
-                <a:ea typeface="宋体" panose="02010600030101010101" pitchFamily="2" charset="-122"/>
-                <a:cs typeface="Times New Roman" panose="02020603050405020304" pitchFamily="18" charset="0"/>
-              </a:rPr>
-              <a:t>drugtoantibodyratio</a:t>
-            </a:r>
-            <a:r>
-              <a:rPr lang="zh-CN" altLang="en-US" sz="2000">
-                <a:latin typeface="Times New Roman" panose="02020603050405020304" pitchFamily="18" charset="0"/>
-                <a:ea typeface="宋体" panose="02010600030101010101" pitchFamily="2" charset="-122"/>
-                <a:cs typeface="Times New Roman" panose="02020603050405020304" pitchFamily="18" charset="0"/>
-              </a:rPr>
-              <a:t>）的组分：生产得到的</a:t>
-            </a:r>
-            <a:r>
-              <a:rPr lang="en-US" altLang="zh-CN" sz="2000">
-                <a:latin typeface="Times New Roman" panose="02020603050405020304" pitchFamily="18" charset="0"/>
-                <a:ea typeface="宋体" panose="02010600030101010101" pitchFamily="2" charset="-122"/>
-                <a:cs typeface="Times New Roman" panose="02020603050405020304" pitchFamily="18" charset="0"/>
-              </a:rPr>
-              <a:t>ADC</a:t>
-            </a:r>
-            <a:r>
-              <a:rPr lang="zh-CN" altLang="en-US" sz="2000">
-                <a:latin typeface="Times New Roman" panose="02020603050405020304" pitchFamily="18" charset="0"/>
-                <a:ea typeface="宋体" panose="02010600030101010101" pitchFamily="2" charset="-122"/>
-                <a:cs typeface="Times New Roman" panose="02020603050405020304" pitchFamily="18" charset="0"/>
-              </a:rPr>
-              <a:t>通常是包含不同数量药物分子的抗体混合物（例如，</a:t>
-            </a:r>
-            <a:r>
-              <a:rPr lang="en-US" altLang="zh-CN" sz="2000">
-                <a:latin typeface="Times New Roman" panose="02020603050405020304" pitchFamily="18" charset="0"/>
-                <a:ea typeface="宋体" panose="02010600030101010101" pitchFamily="2" charset="-122"/>
-                <a:cs typeface="Times New Roman" panose="02020603050405020304" pitchFamily="18" charset="0"/>
-              </a:rPr>
-              <a:t>DAR=0,2,4,6,8</a:t>
-            </a:r>
-            <a:r>
-              <a:rPr lang="zh-CN" altLang="en-US" sz="2000">
-                <a:latin typeface="Times New Roman" panose="02020603050405020304" pitchFamily="18" charset="0"/>
-                <a:ea typeface="宋体" panose="02010600030101010101" pitchFamily="2" charset="-122"/>
-                <a:cs typeface="Times New Roman" panose="02020603050405020304" pitchFamily="18" charset="0"/>
-              </a:rPr>
-              <a:t>的混合物）。这个</a:t>
-            </a:r>
-            <a:r>
-              <a:rPr lang="en-US" altLang="zh-CN" sz="2000">
-                <a:latin typeface="Times New Roman" panose="02020603050405020304" pitchFamily="18" charset="0"/>
-                <a:ea typeface="宋体" panose="02010600030101010101" pitchFamily="2" charset="-122"/>
-                <a:cs typeface="Times New Roman" panose="02020603050405020304" pitchFamily="18" charset="0"/>
-              </a:rPr>
-              <a:t>DAR</a:t>
-            </a:r>
-            <a:r>
-              <a:rPr lang="zh-CN" altLang="en-US" sz="2000">
-                <a:latin typeface="Times New Roman" panose="02020603050405020304" pitchFamily="18" charset="0"/>
-                <a:ea typeface="宋体" panose="02010600030101010101" pitchFamily="2" charset="-122"/>
-                <a:cs typeface="Times New Roman" panose="02020603050405020304" pitchFamily="18" charset="0"/>
-              </a:rPr>
-              <a:t>值是影响药物疗效和安全性的关键质量属性：</a:t>
-            </a:r>
-            <a:r>
-              <a:rPr lang="en-US" altLang="zh-CN" sz="2000">
-                <a:latin typeface="Times New Roman" panose="02020603050405020304" pitchFamily="18" charset="0"/>
-                <a:ea typeface="宋体" panose="02010600030101010101" pitchFamily="2" charset="-122"/>
-                <a:cs typeface="Times New Roman" panose="02020603050405020304" pitchFamily="18" charset="0"/>
-              </a:rPr>
-              <a:t>DAR</a:t>
-            </a:r>
-            <a:r>
-              <a:rPr lang="zh-CN" altLang="en-US" sz="2000">
-                <a:latin typeface="Times New Roman" panose="02020603050405020304" pitchFamily="18" charset="0"/>
-                <a:ea typeface="宋体" panose="02010600030101010101" pitchFamily="2" charset="-122"/>
-                <a:cs typeface="Times New Roman" panose="02020603050405020304" pitchFamily="18" charset="0"/>
-              </a:rPr>
-              <a:t>过高的组分可能导致聚集和体内清除过快，影响安全性和药效；</a:t>
-            </a:r>
-            <a:r>
-              <a:rPr lang="en-US" altLang="zh-CN" sz="2000">
-                <a:latin typeface="Times New Roman" panose="02020603050405020304" pitchFamily="18" charset="0"/>
-                <a:ea typeface="宋体" panose="02010600030101010101" pitchFamily="2" charset="-122"/>
-                <a:cs typeface="Times New Roman" panose="02020603050405020304" pitchFamily="18" charset="0"/>
-              </a:rPr>
-              <a:t>DAR</a:t>
-            </a:r>
-            <a:r>
-              <a:rPr lang="zh-CN" altLang="en-US" sz="2000">
-                <a:latin typeface="Times New Roman" panose="02020603050405020304" pitchFamily="18" charset="0"/>
-                <a:ea typeface="宋体" panose="02010600030101010101" pitchFamily="2" charset="-122"/>
-                <a:cs typeface="Times New Roman" panose="02020603050405020304" pitchFamily="18" charset="0"/>
-              </a:rPr>
-              <a:t>过低的组分药效不足。</a:t>
-            </a:r>
-          </a:p>
-          <a:p>
-            <a:endParaRPr lang="zh-CN" altLang="en-US" sz="2000">
-              <a:latin typeface="Times New Roman" panose="02020603050405020304" pitchFamily="18" charset="0"/>
-              <a:ea typeface="宋体" panose="02010600030101010101" pitchFamily="2" charset="-122"/>
-              <a:cs typeface="Times New Roman" panose="02020603050405020304" pitchFamily="18" charset="0"/>
-            </a:endParaRPr>
-          </a:p>
-          <a:p>
-            <a:pPr marL="285750" indent="-285750">
-              <a:buFont typeface="Wingdings" panose="05000000000000000000" charset="0"/>
-              <a:buChar char="Ø"/>
-            </a:pPr>
-            <a:r>
-              <a:rPr lang="zh-CN" altLang="en-US" sz="2000">
-                <a:latin typeface="Times New Roman" panose="02020603050405020304" pitchFamily="18" charset="0"/>
-                <a:ea typeface="宋体" panose="02010600030101010101" pitchFamily="2" charset="-122"/>
-                <a:cs typeface="Times New Roman" panose="02020603050405020304" pitchFamily="18" charset="0"/>
-              </a:rPr>
-              <a:t>去除聚集体：在</a:t>
-            </a:r>
-            <a:r>
-              <a:rPr lang="en-US" altLang="zh-CN" sz="2000">
-                <a:latin typeface="Times New Roman" panose="02020603050405020304" pitchFamily="18" charset="0"/>
-                <a:ea typeface="宋体" panose="02010600030101010101" pitchFamily="2" charset="-122"/>
-                <a:cs typeface="Times New Roman" panose="02020603050405020304" pitchFamily="18" charset="0"/>
-              </a:rPr>
-              <a:t>ADC</a:t>
-            </a:r>
-            <a:r>
-              <a:rPr lang="zh-CN" altLang="en-US" sz="2000">
-                <a:latin typeface="Times New Roman" panose="02020603050405020304" pitchFamily="18" charset="0"/>
-                <a:ea typeface="宋体" panose="02010600030101010101" pitchFamily="2" charset="-122"/>
-                <a:cs typeface="Times New Roman" panose="02020603050405020304" pitchFamily="18" charset="0"/>
-              </a:rPr>
-              <a:t>的生产和纯化过程中，蛋白质可能会形成聚集体。这些聚集体是一个主要的制造难题，因为它会促进免疫原性，可能导致严重的不良反应。</a:t>
-            </a:r>
-          </a:p>
-          <a:p>
-            <a:endParaRPr lang="zh-CN" altLang="en-US" sz="2000">
-              <a:latin typeface="Times New Roman" panose="02020603050405020304" pitchFamily="18" charset="0"/>
-              <a:ea typeface="宋体" panose="02010600030101010101" pitchFamily="2" charset="-122"/>
-              <a:cs typeface="Times New Roman" panose="02020603050405020304" pitchFamily="18" charset="0"/>
-            </a:endParaRPr>
-          </a:p>
-          <a:p>
-            <a:pPr marL="285750" indent="-285750">
-              <a:buFont typeface="Wingdings" panose="05000000000000000000" charset="0"/>
-              <a:buChar char="Ø"/>
-            </a:pPr>
-            <a:r>
-              <a:rPr lang="zh-CN" altLang="en-US" sz="2000">
-                <a:latin typeface="Times New Roman" panose="02020603050405020304" pitchFamily="18" charset="0"/>
-                <a:ea typeface="宋体" panose="02010600030101010101" pitchFamily="2" charset="-122"/>
-                <a:cs typeface="Times New Roman" panose="02020603050405020304" pitchFamily="18" charset="0"/>
-              </a:rPr>
-              <a:t>清除游离的药物连接子及相关杂质：</a:t>
-            </a:r>
-            <a:r>
-              <a:rPr lang="en-US" altLang="zh-CN" sz="2000">
-                <a:latin typeface="Times New Roman" panose="02020603050405020304" pitchFamily="18" charset="0"/>
-                <a:ea typeface="宋体" panose="02010600030101010101" pitchFamily="2" charset="-122"/>
-                <a:cs typeface="Times New Roman" panose="02020603050405020304" pitchFamily="18" charset="0"/>
-              </a:rPr>
-              <a:t>ADC</a:t>
-            </a:r>
-            <a:r>
-              <a:rPr lang="zh-CN" altLang="en-US" sz="2000">
-                <a:latin typeface="Times New Roman" panose="02020603050405020304" pitchFamily="18" charset="0"/>
-                <a:ea typeface="宋体" panose="02010600030101010101" pitchFamily="2" charset="-122"/>
-                <a:cs typeface="Times New Roman" panose="02020603050405020304" pitchFamily="18" charset="0"/>
-              </a:rPr>
-              <a:t>所携带的小分子</a:t>
-            </a:r>
-            <a:r>
-              <a:rPr lang="en-US" altLang="zh-CN" sz="2000">
-                <a:latin typeface="Times New Roman" panose="02020603050405020304" pitchFamily="18" charset="0"/>
-                <a:ea typeface="宋体" panose="02010600030101010101" pitchFamily="2" charset="-122"/>
-                <a:cs typeface="Times New Roman" panose="02020603050405020304" pitchFamily="18" charset="0"/>
-              </a:rPr>
-              <a:t>“</a:t>
-            </a:r>
-            <a:r>
-              <a:rPr lang="zh-CN" altLang="en-US" sz="2000">
-                <a:latin typeface="Times New Roman" panose="02020603050405020304" pitchFamily="18" charset="0"/>
-                <a:ea typeface="宋体" panose="02010600030101010101" pitchFamily="2" charset="-122"/>
-                <a:cs typeface="Times New Roman" panose="02020603050405020304" pitchFamily="18" charset="0"/>
-              </a:rPr>
-              <a:t>有效载荷</a:t>
-            </a:r>
-            <a:r>
-              <a:rPr lang="en-US" altLang="zh-CN" sz="2000">
-                <a:latin typeface="Times New Roman" panose="02020603050405020304" pitchFamily="18" charset="0"/>
-                <a:ea typeface="宋体" panose="02010600030101010101" pitchFamily="2" charset="-122"/>
-                <a:cs typeface="Times New Roman" panose="02020603050405020304" pitchFamily="18" charset="0"/>
-              </a:rPr>
-              <a:t>”</a:t>
-            </a:r>
-            <a:r>
-              <a:rPr lang="zh-CN" altLang="en-US" sz="2000">
-                <a:latin typeface="Times New Roman" panose="02020603050405020304" pitchFamily="18" charset="0"/>
-                <a:ea typeface="宋体" panose="02010600030101010101" pitchFamily="2" charset="-122"/>
-                <a:cs typeface="Times New Roman" panose="02020603050405020304" pitchFamily="18" charset="0"/>
-              </a:rPr>
-              <a:t>（</a:t>
-            </a:r>
-            <a:r>
-              <a:rPr lang="en-US" altLang="zh-CN" sz="2000">
-                <a:latin typeface="Times New Roman" panose="02020603050405020304" pitchFamily="18" charset="0"/>
-                <a:ea typeface="宋体" panose="02010600030101010101" pitchFamily="2" charset="-122"/>
-                <a:cs typeface="Times New Roman" panose="02020603050405020304" pitchFamily="18" charset="0"/>
-              </a:rPr>
-              <a:t>payload</a:t>
-            </a:r>
-            <a:r>
-              <a:rPr lang="zh-CN" altLang="en-US" sz="2000">
-                <a:latin typeface="Times New Roman" panose="02020603050405020304" pitchFamily="18" charset="0"/>
-                <a:ea typeface="宋体" panose="02010600030101010101" pitchFamily="2" charset="-122"/>
-                <a:cs typeface="Times New Roman" panose="02020603050405020304" pitchFamily="18" charset="0"/>
-              </a:rPr>
-              <a:t>）通常具有极高的细胞毒性。因此，在偶联反应后，任何残留的、未结合到抗体上的游离药物连接子都必须被彻底清除，以确保最终药品的安全性。</a:t>
-            </a:r>
+              <a:rPr lang="zh-CN" altLang="en-US" sz="2400" b="1" dirty="0"/>
+              <a:t>问题三：</a:t>
+            </a:r>
+            <a:endParaRPr lang="en-US" altLang="zh-CN" sz="2400" b="1" dirty="0"/>
+          </a:p>
+          <a:p>
+            <a:r>
+              <a:rPr lang="zh-CN" altLang="en-US" sz="2000" dirty="0">
+                <a:latin typeface="Times New Roman" panose="02020603050405020304" pitchFamily="18" charset="0"/>
+                <a:ea typeface="宋体" panose="02010600030101010101" pitchFamily="2" charset="-122"/>
+                <a:cs typeface="Times New Roman" panose="02020603050405020304" pitchFamily="18" charset="0"/>
+              </a:rPr>
+              <a:t>清除游离的药物连接子及相关杂质</a:t>
+            </a:r>
+            <a:endParaRPr lang="en-US" altLang="zh-CN" sz="2000" dirty="0"/>
+          </a:p>
+          <a:p>
+            <a:endParaRPr lang="zh-CN" altLang="en-US" dirty="0"/>
           </a:p>
         </p:txBody>
       </p:sp>

</xml_diff>

<commit_message>
vault backup: 2025-10-24 22:29:21
</commit_message>
<xml_diff>
--- a/生物分离工程/第十组汇报ppt.pptx
+++ b/生物分离工程/第十组汇报ppt.pptx
@@ -1552,6 +1552,90 @@
     <p:extLst>
       <p:ext uri="{BB962C8B-B14F-4D97-AF65-F5344CB8AC3E}">
         <p14:creationId xmlns:p14="http://schemas.microsoft.com/office/powerpoint/2010/main" val="559443968"/>
+      </p:ext>
+    </p:extLst>
+  </p:cSld>
+  <p:clrMapOvr>
+    <a:masterClrMapping/>
+  </p:clrMapOvr>
+</p:notes>
+</file>
+
+<file path=ppt/notesSlides/notesSlide17.xml><?xml version="1.0" encoding="utf-8"?>
+<p:notes xmlns:a="http://schemas.openxmlformats.org/drawingml/2006/main" xmlns:r="http://schemas.openxmlformats.org/officeDocument/2006/relationships" xmlns:p="http://schemas.openxmlformats.org/presentationml/2006/main">
+  <p:cSld>
+    <p:spTree>
+      <p:nvGrpSpPr>
+        <p:cNvPr id="1" name=""/>
+        <p:cNvGrpSpPr/>
+        <p:nvPr/>
+      </p:nvGrpSpPr>
+      <p:grpSpPr>
+        <a:xfrm>
+          <a:off x="0" y="0"/>
+          <a:ext cx="0" cy="0"/>
+          <a:chOff x="0" y="0"/>
+          <a:chExt cx="0" cy="0"/>
+        </a:xfrm>
+      </p:grpSpPr>
+      <p:sp>
+        <p:nvSpPr>
+          <p:cNvPr id="2" name="幻灯片图像占位符 1"/>
+          <p:cNvSpPr>
+            <a:spLocks noGrp="1" noRot="1" noChangeAspect="1"/>
+          </p:cNvSpPr>
+          <p:nvPr>
+            <p:ph type="sldImg"/>
+          </p:nvPr>
+        </p:nvSpPr>
+        <p:spPr/>
+      </p:sp>
+      <p:sp>
+        <p:nvSpPr>
+          <p:cNvPr id="3" name="备注占位符 2"/>
+          <p:cNvSpPr>
+            <a:spLocks noGrp="1"/>
+          </p:cNvSpPr>
+          <p:nvPr>
+            <p:ph type="body" idx="1"/>
+          </p:nvPr>
+        </p:nvSpPr>
+        <p:spPr/>
+        <p:txBody>
+          <a:bodyPr/>
+          <a:lstStyle/>
+          <a:p>
+            <a:endParaRPr lang="zh-CN" altLang="en-US" dirty="0"/>
+          </a:p>
+        </p:txBody>
+      </p:sp>
+      <p:sp>
+        <p:nvSpPr>
+          <p:cNvPr id="4" name="灯片编号占位符 3"/>
+          <p:cNvSpPr>
+            <a:spLocks noGrp="1"/>
+          </p:cNvSpPr>
+          <p:nvPr>
+            <p:ph type="sldNum" sz="quarter" idx="5"/>
+          </p:nvPr>
+        </p:nvSpPr>
+        <p:spPr/>
+        <p:txBody>
+          <a:bodyPr/>
+          <a:lstStyle/>
+          <a:p>
+            <a:fld id="{337F53EF-5364-44E3-BFA2-84231755F7E3}" type="slidenum">
+              <a:rPr lang="zh-CN" altLang="en-US" smtClean="0"/>
+              <a:t>22</a:t>
+            </a:fld>
+            <a:endParaRPr lang="zh-CN" altLang="en-US"/>
+          </a:p>
+        </p:txBody>
+      </p:sp>
+    </p:spTree>
+    <p:extLst>
+      <p:ext uri="{BB962C8B-B14F-4D97-AF65-F5344CB8AC3E}">
+        <p14:creationId xmlns:p14="http://schemas.microsoft.com/office/powerpoint/2010/main" val="2481183197"/>
       </p:ext>
     </p:extLst>
   </p:cSld>
@@ -14744,7 +14828,7 @@
           <a:lstStyle/>
           <a:p>
             <a:r>
-              <a:rPr lang="zh-CN" altLang="en-US" sz="2000" b="1">
+              <a:rPr lang="zh-CN" altLang="en-US" sz="2000" b="1" dirty="0">
                 <a:latin typeface="宋体" panose="02010600030101010101" pitchFamily="2" charset="-122"/>
                 <a:ea typeface="宋体" panose="02010600030101010101" pitchFamily="2" charset="-122"/>
                 <a:cs typeface="宋体" panose="02010600030101010101" pitchFamily="2" charset="-122"/>
@@ -14752,7 +14836,7 @@
               <a:t>电荷调控切向流过滤技术</a:t>
             </a:r>
             <a:r>
-              <a:rPr lang="en-US" altLang="zh-CN" sz="2000" b="1">
+              <a:rPr lang="en-US" altLang="zh-CN" sz="2000" b="1" dirty="0">
                 <a:latin typeface="宋体" panose="02010600030101010101" pitchFamily="2" charset="-122"/>
                 <a:ea typeface="宋体" panose="02010600030101010101" pitchFamily="2" charset="-122"/>
                 <a:cs typeface="宋体" panose="02010600030101010101" pitchFamily="2" charset="-122"/>
@@ -14761,7 +14845,7 @@
             </a:r>
           </a:p>
           <a:p>
-            <a:endParaRPr lang="en-US" altLang="zh-CN" sz="2000">
+            <a:endParaRPr lang="en-US" altLang="zh-CN" sz="2000" dirty="0">
               <a:latin typeface="宋体" panose="02010600030101010101" pitchFamily="2" charset="-122"/>
               <a:ea typeface="宋体" panose="02010600030101010101" pitchFamily="2" charset="-122"/>
               <a:cs typeface="宋体" panose="02010600030101010101" pitchFamily="2" charset="-122"/>
@@ -14769,7 +14853,7 @@
           </a:p>
           <a:p>
             <a:r>
-              <a:rPr lang="zh-CN" altLang="en-US" sz="2000">
+              <a:rPr lang="zh-CN" altLang="en-US" sz="2000" dirty="0">
                 <a:latin typeface="宋体" panose="02010600030101010101" pitchFamily="2" charset="-122"/>
                 <a:ea typeface="宋体" panose="02010600030101010101" pitchFamily="2" charset="-122"/>
                 <a:cs typeface="宋体" panose="02010600030101010101" pitchFamily="2" charset="-122"/>
@@ -14777,7 +14861,7 @@
               <a:t>通过对膜表面进行电荷修饰（如引入阳离子基团），利用</a:t>
             </a:r>
             <a:r>
-              <a:rPr lang="en-US" altLang="zh-CN" sz="2000">
+              <a:rPr lang="en-US" altLang="zh-CN" sz="2000" dirty="0">
                 <a:latin typeface="宋体" panose="02010600030101010101" pitchFamily="2" charset="-122"/>
                 <a:ea typeface="宋体" panose="02010600030101010101" pitchFamily="2" charset="-122"/>
                 <a:cs typeface="宋体" panose="02010600030101010101" pitchFamily="2" charset="-122"/>
@@ -14785,7 +14869,7 @@
               <a:t>“</a:t>
             </a:r>
             <a:r>
-              <a:rPr lang="zh-CN" altLang="en-US" sz="2000">
+              <a:rPr lang="zh-CN" altLang="en-US" sz="2000" dirty="0">
                 <a:latin typeface="宋体" panose="02010600030101010101" pitchFamily="2" charset="-122"/>
                 <a:ea typeface="宋体" panose="02010600030101010101" pitchFamily="2" charset="-122"/>
                 <a:cs typeface="宋体" panose="02010600030101010101" pitchFamily="2" charset="-122"/>
@@ -14793,7 +14877,7 @@
               <a:t>电荷相互作用</a:t>
             </a:r>
             <a:r>
-              <a:rPr lang="en-US" altLang="zh-CN" sz="2000">
+              <a:rPr lang="en-US" altLang="zh-CN" sz="2000" dirty="0">
                 <a:latin typeface="宋体" panose="02010600030101010101" pitchFamily="2" charset="-122"/>
                 <a:ea typeface="宋体" panose="02010600030101010101" pitchFamily="2" charset="-122"/>
                 <a:cs typeface="宋体" panose="02010600030101010101" pitchFamily="2" charset="-122"/>
@@ -14801,7 +14885,7 @@
               <a:t>”</a:t>
             </a:r>
             <a:r>
-              <a:rPr lang="zh-CN" altLang="en-US" sz="2000">
+              <a:rPr lang="zh-CN" altLang="en-US" sz="2000" dirty="0">
                 <a:latin typeface="宋体" panose="02010600030101010101" pitchFamily="2" charset="-122"/>
                 <a:ea typeface="宋体" panose="02010600030101010101" pitchFamily="2" charset="-122"/>
                 <a:cs typeface="宋体" panose="02010600030101010101" pitchFamily="2" charset="-122"/>
@@ -14809,7 +14893,7 @@
               <a:t>增强分离能力，突破了传统</a:t>
             </a:r>
             <a:r>
-              <a:rPr lang="en-US" altLang="zh-CN" sz="2000">
+              <a:rPr lang="en-US" altLang="zh-CN" sz="2000" dirty="0">
                 <a:latin typeface="宋体" panose="02010600030101010101" pitchFamily="2" charset="-122"/>
                 <a:ea typeface="宋体" panose="02010600030101010101" pitchFamily="2" charset="-122"/>
                 <a:cs typeface="宋体" panose="02010600030101010101" pitchFamily="2" charset="-122"/>
@@ -14817,7 +14901,7 @@
               <a:t>TFF“</a:t>
             </a:r>
             <a:r>
-              <a:rPr lang="zh-CN" altLang="en-US" sz="2000">
+              <a:rPr lang="zh-CN" altLang="en-US" sz="2000" dirty="0">
                 <a:latin typeface="宋体" panose="02010600030101010101" pitchFamily="2" charset="-122"/>
                 <a:ea typeface="宋体" panose="02010600030101010101" pitchFamily="2" charset="-122"/>
                 <a:cs typeface="宋体" panose="02010600030101010101" pitchFamily="2" charset="-122"/>
@@ -14825,7 +14909,7 @@
               <a:t>仅靠分子量分离</a:t>
             </a:r>
             <a:r>
-              <a:rPr lang="en-US" altLang="zh-CN" sz="2000">
+              <a:rPr lang="en-US" altLang="zh-CN" sz="2000" dirty="0">
                 <a:latin typeface="宋体" panose="02010600030101010101" pitchFamily="2" charset="-122"/>
                 <a:ea typeface="宋体" panose="02010600030101010101" pitchFamily="2" charset="-122"/>
                 <a:cs typeface="宋体" panose="02010600030101010101" pitchFamily="2" charset="-122"/>
@@ -14833,7 +14917,7 @@
               <a:t>”</a:t>
             </a:r>
             <a:r>
-              <a:rPr lang="zh-CN" altLang="en-US" sz="2000">
+              <a:rPr lang="zh-CN" altLang="en-US" sz="2000" dirty="0">
                 <a:latin typeface="宋体" panose="02010600030101010101" pitchFamily="2" charset="-122"/>
                 <a:ea typeface="宋体" panose="02010600030101010101" pitchFamily="2" charset="-122"/>
                 <a:cs typeface="宋体" panose="02010600030101010101" pitchFamily="2" charset="-122"/>
@@ -14842,7 +14926,7 @@
             </a:r>
           </a:p>
           <a:p>
-            <a:endParaRPr lang="zh-CN" altLang="en-US" sz="2000">
+            <a:endParaRPr lang="zh-CN" altLang="en-US" sz="2000" dirty="0">
               <a:latin typeface="宋体" panose="02010600030101010101" pitchFamily="2" charset="-122"/>
               <a:ea typeface="宋体" panose="02010600030101010101" pitchFamily="2" charset="-122"/>
               <a:cs typeface="宋体" panose="02010600030101010101" pitchFamily="2" charset="-122"/>
@@ -14854,7 +14938,7 @@
               <a:buChar char="Ø"/>
             </a:pPr>
             <a:r>
-              <a:rPr lang="zh-CN" altLang="en-US" sz="2000">
+              <a:rPr lang="zh-CN" altLang="en-US" sz="2000" dirty="0">
                 <a:latin typeface="宋体" panose="02010600030101010101" pitchFamily="2" charset="-122"/>
                 <a:ea typeface="宋体" panose="02010600030101010101" pitchFamily="2" charset="-122"/>
                 <a:cs typeface="宋体" panose="02010600030101010101" pitchFamily="2" charset="-122"/>
@@ -14862,7 +14946,7 @@
               <a:t>去除小分子杂质（取代第一步</a:t>
             </a:r>
             <a:r>
-              <a:rPr lang="en-US" altLang="zh-CN" sz="2000">
+              <a:rPr lang="en-US" altLang="zh-CN" sz="2000" dirty="0">
                 <a:latin typeface="宋体" panose="02010600030101010101" pitchFamily="2" charset="-122"/>
                 <a:ea typeface="宋体" panose="02010600030101010101" pitchFamily="2" charset="-122"/>
                 <a:cs typeface="宋体" panose="02010600030101010101" pitchFamily="2" charset="-122"/>
@@ -14870,7 +14954,7 @@
               <a:t>TFF</a:t>
             </a:r>
             <a:r>
-              <a:rPr lang="zh-CN" altLang="en-US" sz="2000">
+              <a:rPr lang="zh-CN" altLang="en-US" sz="2000" dirty="0">
                 <a:latin typeface="宋体" panose="02010600030101010101" pitchFamily="2" charset="-122"/>
                 <a:ea typeface="宋体" panose="02010600030101010101" pitchFamily="2" charset="-122"/>
                 <a:cs typeface="宋体" panose="02010600030101010101" pitchFamily="2" charset="-122"/>
@@ -14884,7 +14968,7 @@
               <a:buChar char="Ø"/>
             </a:pPr>
             <a:r>
-              <a:rPr lang="zh-CN" altLang="en-US" sz="2000">
+              <a:rPr lang="zh-CN" altLang="en-US" sz="2000" dirty="0">
                 <a:latin typeface="宋体" panose="02010600030101010101" pitchFamily="2" charset="-122"/>
                 <a:ea typeface="宋体" panose="02010600030101010101" pitchFamily="2" charset="-122"/>
                 <a:cs typeface="宋体" panose="02010600030101010101" pitchFamily="2" charset="-122"/>
@@ -14892,7 +14976,7 @@
               <a:t>分离</a:t>
             </a:r>
             <a:r>
-              <a:rPr lang="en-US" altLang="zh-CN" sz="2000">
+              <a:rPr lang="en-US" altLang="zh-CN" sz="2000" dirty="0">
                 <a:latin typeface="宋体" panose="02010600030101010101" pitchFamily="2" charset="-122"/>
                 <a:ea typeface="宋体" panose="02010600030101010101" pitchFamily="2" charset="-122"/>
                 <a:cs typeface="宋体" panose="02010600030101010101" pitchFamily="2" charset="-122"/>
@@ -14900,7 +14984,7 @@
               <a:t>DAR</a:t>
             </a:r>
             <a:r>
-              <a:rPr lang="zh-CN" altLang="en-US" sz="2000">
+              <a:rPr lang="zh-CN" altLang="en-US" sz="2000" dirty="0">
                 <a:latin typeface="宋体" panose="02010600030101010101" pitchFamily="2" charset="-122"/>
                 <a:ea typeface="宋体" panose="02010600030101010101" pitchFamily="2" charset="-122"/>
                 <a:cs typeface="宋体" panose="02010600030101010101" pitchFamily="2" charset="-122"/>
@@ -14910,7 +14994,7 @@
           </a:p>
           <a:p>
             <a:r>
-              <a:rPr lang="zh-CN" altLang="en-US" sz="2000">
+              <a:rPr lang="zh-CN" altLang="en-US" sz="2000" dirty="0">
                 <a:latin typeface="宋体" panose="02010600030101010101" pitchFamily="2" charset="-122"/>
                 <a:ea typeface="宋体" panose="02010600030101010101" pitchFamily="2" charset="-122"/>
                 <a:cs typeface="宋体" panose="02010600030101010101" pitchFamily="2" charset="-122"/>
@@ -14918,7 +15002,7 @@
               <a:t>不同</a:t>
             </a:r>
             <a:r>
-              <a:rPr lang="en-US" altLang="zh-CN" sz="2000">
+              <a:rPr lang="en-US" altLang="zh-CN" sz="2000" dirty="0">
                 <a:latin typeface="宋体" panose="02010600030101010101" pitchFamily="2" charset="-122"/>
                 <a:ea typeface="宋体" panose="02010600030101010101" pitchFamily="2" charset="-122"/>
                 <a:cs typeface="宋体" panose="02010600030101010101" pitchFamily="2" charset="-122"/>
@@ -14926,7 +15010,7 @@
               <a:t>DAR</a:t>
             </a:r>
             <a:r>
-              <a:rPr lang="zh-CN" altLang="en-US" sz="2000">
+              <a:rPr lang="zh-CN" altLang="en-US" sz="2000" dirty="0">
                 <a:latin typeface="宋体" panose="02010600030101010101" pitchFamily="2" charset="-122"/>
                 <a:ea typeface="宋体" panose="02010600030101010101" pitchFamily="2" charset="-122"/>
                 <a:cs typeface="宋体" panose="02010600030101010101" pitchFamily="2" charset="-122"/>
@@ -14934,7 +15018,7 @@
               <a:t>值的</a:t>
             </a:r>
             <a:r>
-              <a:rPr lang="en-US" altLang="zh-CN" sz="2000">
+              <a:rPr lang="en-US" altLang="zh-CN" sz="2000" dirty="0">
                 <a:latin typeface="宋体" panose="02010600030101010101" pitchFamily="2" charset="-122"/>
                 <a:ea typeface="宋体" panose="02010600030101010101" pitchFamily="2" charset="-122"/>
                 <a:cs typeface="宋体" panose="02010600030101010101" pitchFamily="2" charset="-122"/>
@@ -14942,75 +15026,65 @@
               <a:t>ADC</a:t>
             </a:r>
             <a:r>
-              <a:rPr lang="zh-CN" altLang="en-US" sz="2000">
+              <a:rPr lang="zh-CN" altLang="en-US" sz="2000" dirty="0">
                 <a:latin typeface="宋体" panose="02010600030101010101" pitchFamily="2" charset="-122"/>
                 <a:ea typeface="宋体" panose="02010600030101010101" pitchFamily="2" charset="-122"/>
                 <a:cs typeface="宋体" panose="02010600030101010101" pitchFamily="2" charset="-122"/>
               </a:rPr>
-              <a:t>分子，其表面的电荷分布和等</a:t>
-            </a:r>
-          </a:p>
-          <a:p>
-            <a:r>
-              <a:rPr lang="zh-CN" altLang="en-US" sz="2000">
+              <a:t>分子，其表面的电荷分布和等电点是不同的。通过精确调控</a:t>
+            </a:r>
+            <a:r>
+              <a:rPr lang="en-US" altLang="zh-CN" sz="2000" dirty="0">
                 <a:latin typeface="宋体" panose="02010600030101010101" pitchFamily="2" charset="-122"/>
                 <a:ea typeface="宋体" panose="02010600030101010101" pitchFamily="2" charset="-122"/>
                 <a:cs typeface="宋体" panose="02010600030101010101" pitchFamily="2" charset="-122"/>
               </a:rPr>
-              <a:t>电点是不同的。通过精确调控</a:t>
-            </a:r>
-            <a:r>
-              <a:rPr lang="en-US" altLang="zh-CN" sz="2000">
+              <a:t>pH</a:t>
+            </a:r>
+            <a:r>
+              <a:rPr lang="zh-CN" altLang="en-US" sz="2000" dirty="0">
                 <a:latin typeface="宋体" panose="02010600030101010101" pitchFamily="2" charset="-122"/>
                 <a:ea typeface="宋体" panose="02010600030101010101" pitchFamily="2" charset="-122"/>
                 <a:cs typeface="宋体" panose="02010600030101010101" pitchFamily="2" charset="-122"/>
               </a:rPr>
-              <a:t>pH</a:t>
-            </a:r>
-            <a:r>
-              <a:rPr lang="zh-CN" altLang="en-US" sz="2000">
+              <a:t>和电场，让不想要的组分因电场力的作用更容易穿过膜，或让最想要的组分在膜表面富集，从而实现分离。这相当于在过滤的同时进行了一次离子交换。</a:t>
+            </a:r>
+          </a:p>
+          <a:p>
+            <a:r>
+              <a:rPr lang="zh-CN" altLang="en-US" sz="2000" dirty="0">
                 <a:latin typeface="宋体" panose="02010600030101010101" pitchFamily="2" charset="-122"/>
                 <a:ea typeface="宋体" panose="02010600030101010101" pitchFamily="2" charset="-122"/>
                 <a:cs typeface="宋体" panose="02010600030101010101" pitchFamily="2" charset="-122"/>
               </a:rPr>
-              <a:t>和电场，让不想要的组分因电场力的作用更容易穿过膜，或让最想要的组分在膜表面富集，从而实现分离。这相当于在过滤的同时进行了一次离子交换。</a:t>
-            </a:r>
-          </a:p>
-          <a:p>
-            <a:r>
-              <a:rPr lang="zh-CN" altLang="en-US" sz="2000">
+              <a:t>去除聚体：聚体不仅尺寸更大，其表面电荷特性也与单体不同。可以设定电场条件，主动</a:t>
+            </a:r>
+            <a:r>
+              <a:rPr lang="en-US" altLang="zh-CN" sz="2000" dirty="0">
                 <a:latin typeface="宋体" panose="02010600030101010101" pitchFamily="2" charset="-122"/>
                 <a:ea typeface="宋体" panose="02010600030101010101" pitchFamily="2" charset="-122"/>
                 <a:cs typeface="宋体" panose="02010600030101010101" pitchFamily="2" charset="-122"/>
               </a:rPr>
-              <a:t>去除聚体：聚体不仅尺寸更大，其表面电荷特性也与单体不同。可以设定电场条件，主动</a:t>
-            </a:r>
-            <a:r>
-              <a:rPr lang="en-US" altLang="zh-CN" sz="2000">
+              <a:t>“</a:t>
+            </a:r>
+            <a:r>
+              <a:rPr lang="zh-CN" altLang="en-US" sz="2000" dirty="0">
                 <a:latin typeface="宋体" panose="02010600030101010101" pitchFamily="2" charset="-122"/>
                 <a:ea typeface="宋体" panose="02010600030101010101" pitchFamily="2" charset="-122"/>
                 <a:cs typeface="宋体" panose="02010600030101010101" pitchFamily="2" charset="-122"/>
               </a:rPr>
-              <a:t>“</a:t>
-            </a:r>
-            <a:r>
-              <a:rPr lang="zh-CN" altLang="en-US" sz="2000">
+              <a:t>排斥</a:t>
+            </a:r>
+            <a:r>
+              <a:rPr lang="en-US" altLang="zh-CN" sz="2000" dirty="0">
                 <a:latin typeface="宋体" panose="02010600030101010101" pitchFamily="2" charset="-122"/>
                 <a:ea typeface="宋体" panose="02010600030101010101" pitchFamily="2" charset="-122"/>
                 <a:cs typeface="宋体" panose="02010600030101010101" pitchFamily="2" charset="-122"/>
               </a:rPr>
-              <a:t>排斥</a:t>
-            </a:r>
-            <a:r>
-              <a:rPr lang="en-US" altLang="zh-CN" sz="2000">
-                <a:latin typeface="宋体" panose="02010600030101010101" pitchFamily="2" charset="-122"/>
-                <a:ea typeface="宋体" panose="02010600030101010101" pitchFamily="2" charset="-122"/>
-                <a:cs typeface="宋体" panose="02010600030101010101" pitchFamily="2" charset="-122"/>
-              </a:rPr>
               <a:t>”</a:t>
             </a:r>
             <a:r>
-              <a:rPr lang="zh-CN" altLang="en-US" sz="2000">
+              <a:rPr lang="zh-CN" altLang="en-US" sz="2000" dirty="0">
                 <a:latin typeface="宋体" panose="02010600030101010101" pitchFamily="2" charset="-122"/>
                 <a:ea typeface="宋体" panose="02010600030101010101" pitchFamily="2" charset="-122"/>
                 <a:cs typeface="宋体" panose="02010600030101010101" pitchFamily="2" charset="-122"/>
@@ -15024,7 +15098,7 @@
               <a:buChar char="Ø"/>
             </a:pPr>
             <a:r>
-              <a:rPr lang="zh-CN" altLang="en-US" sz="2000">
+              <a:rPr lang="zh-CN" altLang="en-US" sz="2000" dirty="0">
                 <a:latin typeface="宋体" panose="02010600030101010101" pitchFamily="2" charset="-122"/>
                 <a:ea typeface="宋体" panose="02010600030101010101" pitchFamily="2" charset="-122"/>
                 <a:cs typeface="宋体" panose="02010600030101010101" pitchFamily="2" charset="-122"/>
@@ -15032,7 +15106,7 @@
               <a:t>最终配方缓冲液置换（取代第三步</a:t>
             </a:r>
             <a:r>
-              <a:rPr lang="en-US" altLang="zh-CN" sz="2000">
+              <a:rPr lang="en-US" altLang="zh-CN" sz="2000" dirty="0">
                 <a:latin typeface="宋体" panose="02010600030101010101" pitchFamily="2" charset="-122"/>
                 <a:ea typeface="宋体" panose="02010600030101010101" pitchFamily="2" charset="-122"/>
                 <a:cs typeface="宋体" panose="02010600030101010101" pitchFamily="2" charset="-122"/>
@@ -15040,7 +15114,7 @@
               <a:t>TFF</a:t>
             </a:r>
             <a:r>
-              <a:rPr lang="zh-CN" altLang="en-US" sz="2000">
+              <a:rPr lang="zh-CN" altLang="en-US" sz="2000" dirty="0">
                 <a:latin typeface="宋体" panose="02010600030101010101" pitchFamily="2" charset="-122"/>
                 <a:ea typeface="宋体" panose="02010600030101010101" pitchFamily="2" charset="-122"/>
                 <a:cs typeface="宋体" panose="02010600030101010101" pitchFamily="2" charset="-122"/>
@@ -15054,7 +15128,7 @@
               <a:buNone/>
             </a:pPr>
             <a:r>
-              <a:rPr lang="zh-CN" altLang="en-US" sz="2000">
+              <a:rPr lang="zh-CN" altLang="en-US" sz="2000" dirty="0">
                 <a:latin typeface="宋体" panose="02010600030101010101" pitchFamily="2" charset="-122"/>
                 <a:ea typeface="宋体" panose="02010600030101010101" pitchFamily="2" charset="-122"/>
                 <a:cs typeface="宋体" panose="02010600030101010101" pitchFamily="2" charset="-122"/>
@@ -15062,7 +15136,7 @@
               <a:t>当分离过程完成，达到了我们想要的纯度和</a:t>
             </a:r>
             <a:r>
-              <a:rPr lang="en-US" altLang="zh-CN" sz="2000">
+              <a:rPr lang="en-US" altLang="zh-CN" sz="2000" dirty="0">
                 <a:latin typeface="宋体" panose="02010600030101010101" pitchFamily="2" charset="-122"/>
                 <a:ea typeface="宋体" panose="02010600030101010101" pitchFamily="2" charset="-122"/>
                 <a:cs typeface="宋体" panose="02010600030101010101" pitchFamily="2" charset="-122"/>
@@ -15070,7 +15144,7 @@
               <a:t>DAR</a:t>
             </a:r>
             <a:r>
-              <a:rPr lang="zh-CN" altLang="en-US" sz="2000">
+              <a:rPr lang="zh-CN" altLang="en-US" sz="2000" dirty="0">
                 <a:latin typeface="宋体" panose="02010600030101010101" pitchFamily="2" charset="-122"/>
                 <a:ea typeface="宋体" panose="02010600030101010101" pitchFamily="2" charset="-122"/>
                 <a:cs typeface="宋体" panose="02010600030101010101" pitchFamily="2" charset="-122"/>
@@ -15078,7 +15152,7 @@
               <a:t>分布后，只需关闭电场，这个系统就变回一个标准的</a:t>
             </a:r>
             <a:r>
-              <a:rPr lang="en-US" altLang="zh-CN" sz="2000">
+              <a:rPr lang="en-US" altLang="zh-CN" sz="2000" dirty="0">
                 <a:latin typeface="宋体" panose="02010600030101010101" pitchFamily="2" charset="-122"/>
                 <a:ea typeface="宋体" panose="02010600030101010101" pitchFamily="2" charset="-122"/>
                 <a:cs typeface="宋体" panose="02010600030101010101" pitchFamily="2" charset="-122"/>
@@ -15086,7 +15160,7 @@
               <a:t>TFF</a:t>
             </a:r>
             <a:r>
-              <a:rPr lang="zh-CN" altLang="en-US" sz="2000">
+              <a:rPr lang="zh-CN" altLang="en-US" sz="2000" dirty="0">
                 <a:latin typeface="宋体" panose="02010600030101010101" pitchFamily="2" charset="-122"/>
                 <a:ea typeface="宋体" panose="02010600030101010101" pitchFamily="2" charset="-122"/>
                 <a:cs typeface="宋体" panose="02010600030101010101" pitchFamily="2" charset="-122"/>
@@ -15094,7 +15168,7 @@
               <a:t>装置。我们可以直接用它进行最后的缓冲液置换，将纯化好的</a:t>
             </a:r>
             <a:r>
-              <a:rPr lang="en-US" altLang="zh-CN" sz="2000">
+              <a:rPr lang="en-US" altLang="zh-CN" sz="2000" dirty="0">
                 <a:latin typeface="宋体" panose="02010600030101010101" pitchFamily="2" charset="-122"/>
                 <a:ea typeface="宋体" panose="02010600030101010101" pitchFamily="2" charset="-122"/>
                 <a:cs typeface="宋体" panose="02010600030101010101" pitchFamily="2" charset="-122"/>
@@ -15102,7 +15176,7 @@
               <a:t>ADC</a:t>
             </a:r>
             <a:r>
-              <a:rPr lang="zh-CN" altLang="en-US" sz="2000">
+              <a:rPr lang="zh-CN" altLang="en-US" sz="2000" dirty="0">
                 <a:latin typeface="宋体" panose="02010600030101010101" pitchFamily="2" charset="-122"/>
                 <a:ea typeface="宋体" panose="02010600030101010101" pitchFamily="2" charset="-122"/>
                 <a:cs typeface="宋体" panose="02010600030101010101" pitchFamily="2" charset="-122"/>
@@ -15300,7 +15374,7 @@
           <p:nvPr/>
         </p:nvPicPr>
         <p:blipFill>
-          <a:blip r:embed="rId2">
+          <a:blip r:embed="rId3">
             <a:extLst>
               <a:ext uri="{28A0092B-C50C-407E-A947-70E740481C1C}">
                 <a14:useLocalDpi xmlns:a14="http://schemas.microsoft.com/office/drawing/2010/main" val="0"/>
@@ -15866,51 +15940,6 @@
               <a:latin typeface="黑体" panose="02010609060101010101" pitchFamily="49" charset="-122"/>
               <a:ea typeface="黑体" panose="02010609060101010101" pitchFamily="49" charset="-122"/>
             </a:endParaRPr>
-          </a:p>
-        </p:txBody>
-      </p:sp>
-      <p:sp>
-        <p:nvSpPr>
-          <p:cNvPr id="13" name="文本框 12"/>
-          <p:cNvSpPr txBox="1"/>
-          <p:nvPr/>
-        </p:nvSpPr>
-        <p:spPr>
-          <a:xfrm>
-            <a:off x="2944178" y="5387975"/>
-            <a:ext cx="6303645" cy="829945"/>
-          </a:xfrm>
-          <a:prstGeom prst="rect">
-            <a:avLst/>
-          </a:prstGeom>
-          <a:noFill/>
-        </p:spPr>
-        <p:txBody>
-          <a:bodyPr wrap="square" rtlCol="0">
-            <a:spAutoFit/>
-          </a:bodyPr>
-          <a:lstStyle/>
-          <a:p>
-            <a:pPr algn="ctr"/>
-            <a:r>
-              <a:rPr lang="zh-CN" altLang="en-US" sz="2400" b="1" dirty="0"/>
-              <a:t>查找资料，总结资料，汇报：吕启蒙</a:t>
-            </a:r>
-          </a:p>
-          <a:p>
-            <a:pPr algn="ctr"/>
-            <a:r>
-              <a:rPr lang="zh-CN" altLang="en-US" sz="2400" b="1" dirty="0"/>
-              <a:t>制作</a:t>
-            </a:r>
-            <a:r>
-              <a:rPr lang="en-US" altLang="zh-CN" sz="2400" b="1" dirty="0"/>
-              <a:t>PPT</a:t>
-            </a:r>
-            <a:r>
-              <a:rPr lang="zh-CN" altLang="en-US" sz="2400" b="1" dirty="0"/>
-              <a:t>，答疑：马唐逸农</a:t>
-            </a:r>
           </a:p>
         </p:txBody>
       </p:sp>

</xml_diff>

<commit_message>
vault backup: 2025-10-25 13:44:23
</commit_message>
<xml_diff>
--- a/生物分离工程/第十组汇报ppt.pptx
+++ b/生物分离工程/第十组汇报ppt.pptx
@@ -222,7 +222,7 @@
           <a:p>
             <a:fld id="{0F9B84EA-7D68-4D60-9CB1-D50884785D1C}" type="datetimeFigureOut">
               <a:rPr lang="zh-CN" altLang="en-US" smtClean="0"/>
-              <a:t>2025/10/24</a:t>
+              <a:t>2025/10/25</a:t>
             </a:fld>
             <a:endParaRPr lang="zh-CN" altLang="en-US"/>
           </a:p>
@@ -387,7 +387,7 @@
           <a:p>
             <a:fld id="{CE9EBC71-470F-4178-8939-B7F43C998C3E}" type="datetimeFigureOut">
               <a:rPr lang="zh-CN" altLang="en-US" smtClean="0"/>
-              <a:t>2025/10/24</a:t>
+              <a:t>2025/10/25</a:t>
             </a:fld>
             <a:endParaRPr lang="zh-CN" altLang="en-US"/>
           </a:p>
@@ -3234,7 +3234,7 @@
           <a:p>
             <a:fld id="{6FAC1865-B79A-43E4-B218-34456B6B12C9}" type="datetimeFigureOut">
               <a:rPr lang="zh-CN" altLang="en-US" smtClean="0"/>
-              <a:t>2025/10/24</a:t>
+              <a:t>2025/10/25</a:t>
             </a:fld>
             <a:endParaRPr lang="zh-CN" altLang="en-US"/>
           </a:p>
@@ -3409,7 +3409,7 @@
           <a:p>
             <a:fld id="{6FAC1865-B79A-43E4-B218-34456B6B12C9}" type="datetimeFigureOut">
               <a:rPr lang="zh-CN" altLang="en-US" smtClean="0"/>
-              <a:t>2025/10/24</a:t>
+              <a:t>2025/10/25</a:t>
             </a:fld>
             <a:endParaRPr lang="zh-CN" altLang="en-US"/>
           </a:p>
@@ -3594,7 +3594,7 @@
           <a:p>
             <a:fld id="{6FAC1865-B79A-43E4-B218-34456B6B12C9}" type="datetimeFigureOut">
               <a:rPr lang="zh-CN" altLang="en-US" smtClean="0"/>
-              <a:t>2025/10/24</a:t>
+              <a:t>2025/10/25</a:t>
             </a:fld>
             <a:endParaRPr lang="zh-CN" altLang="en-US"/>
           </a:p>
@@ -3806,7 +3806,7 @@
           <a:p>
             <a:fld id="{6FAC1865-B79A-43E4-B218-34456B6B12C9}" type="datetimeFigureOut">
               <a:rPr lang="zh-CN" altLang="en-US" smtClean="0"/>
-              <a:t>2025/10/24</a:t>
+              <a:t>2025/10/25</a:t>
             </a:fld>
             <a:endParaRPr lang="zh-CN" altLang="en-US"/>
           </a:p>
@@ -4058,7 +4058,7 @@
           <a:p>
             <a:fld id="{6FAC1865-B79A-43E4-B218-34456B6B12C9}" type="datetimeFigureOut">
               <a:rPr lang="zh-CN" altLang="en-US" smtClean="0"/>
-              <a:t>2025/10/24</a:t>
+              <a:t>2025/10/25</a:t>
             </a:fld>
             <a:endParaRPr lang="zh-CN" altLang="en-US"/>
           </a:p>
@@ -4294,7 +4294,7 @@
           <a:p>
             <a:fld id="{6FAC1865-B79A-43E4-B218-34456B6B12C9}" type="datetimeFigureOut">
               <a:rPr lang="zh-CN" altLang="en-US" smtClean="0"/>
-              <a:t>2025/10/24</a:t>
+              <a:t>2025/10/25</a:t>
             </a:fld>
             <a:endParaRPr lang="zh-CN" altLang="en-US"/>
           </a:p>
@@ -4665,7 +4665,7 @@
           <a:p>
             <a:fld id="{6FAC1865-B79A-43E4-B218-34456B6B12C9}" type="datetimeFigureOut">
               <a:rPr lang="zh-CN" altLang="en-US" smtClean="0"/>
-              <a:t>2025/10/24</a:t>
+              <a:t>2025/10/25</a:t>
             </a:fld>
             <a:endParaRPr lang="zh-CN" altLang="en-US"/>
           </a:p>
@@ -4789,7 +4789,7 @@
           <a:p>
             <a:fld id="{6FAC1865-B79A-43E4-B218-34456B6B12C9}" type="datetimeFigureOut">
               <a:rPr lang="zh-CN" altLang="en-US" smtClean="0"/>
-              <a:t>2025/10/24</a:t>
+              <a:t>2025/10/25</a:t>
             </a:fld>
             <a:endParaRPr lang="zh-CN" altLang="en-US"/>
           </a:p>
@@ -4891,7 +4891,7 @@
           <a:p>
             <a:fld id="{6FAC1865-B79A-43E4-B218-34456B6B12C9}" type="datetimeFigureOut">
               <a:rPr lang="zh-CN" altLang="en-US" smtClean="0"/>
-              <a:t>2025/10/24</a:t>
+              <a:t>2025/10/25</a:t>
             </a:fld>
             <a:endParaRPr lang="zh-CN" altLang="en-US"/>
           </a:p>
@@ -5173,7 +5173,7 @@
           <a:p>
             <a:fld id="{6FAC1865-B79A-43E4-B218-34456B6B12C9}" type="datetimeFigureOut">
               <a:rPr lang="zh-CN" altLang="en-US" smtClean="0"/>
-              <a:t>2025/10/24</a:t>
+              <a:t>2025/10/25</a:t>
             </a:fld>
             <a:endParaRPr lang="zh-CN" altLang="en-US"/>
           </a:p>
@@ -5432,7 +5432,7 @@
           <a:p>
             <a:fld id="{6FAC1865-B79A-43E4-B218-34456B6B12C9}" type="datetimeFigureOut">
               <a:rPr lang="zh-CN" altLang="en-US" smtClean="0"/>
-              <a:t>2025/10/24</a:t>
+              <a:t>2025/10/25</a:t>
             </a:fld>
             <a:endParaRPr lang="zh-CN" altLang="en-US"/>
           </a:p>
@@ -5650,7 +5650,7 @@
           <a:p>
             <a:fld id="{6FAC1865-B79A-43E4-B218-34456B6B12C9}" type="datetimeFigureOut">
               <a:rPr lang="zh-CN" altLang="en-US" smtClean="0"/>
-              <a:t>2025/10/24</a:t>
+              <a:t>2025/10/25</a:t>
             </a:fld>
             <a:endParaRPr lang="zh-CN" altLang="en-US"/>
           </a:p>
@@ -7086,23 +7086,7 @@
                 <a:ea typeface="宋体" panose="02010600030101010101" pitchFamily="2" charset="-122"/>
                 <a:cs typeface="Times New Roman" panose="02020603050405020304" pitchFamily="18" charset="0"/>
               </a:rPr>
-              <a:t>使用了两种不同的单克隆抗体</a:t>
-            </a:r>
-            <a:r>
-              <a:rPr lang="en-US" altLang="zh-CN" sz="2000" dirty="0" err="1">
-                <a:latin typeface="Times New Roman" panose="02020603050405020304" pitchFamily="18" charset="0"/>
-                <a:ea typeface="宋体" panose="02010600030101010101" pitchFamily="2" charset="-122"/>
-                <a:cs typeface="Times New Roman" panose="02020603050405020304" pitchFamily="18" charset="0"/>
-              </a:rPr>
-              <a:t>mAb</a:t>
-            </a:r>
-            <a:r>
-              <a:rPr lang="zh-CN" altLang="en-US" sz="2000" dirty="0">
-                <a:latin typeface="Times New Roman" panose="02020603050405020304" pitchFamily="18" charset="0"/>
-                <a:ea typeface="宋体" panose="02010600030101010101" pitchFamily="2" charset="-122"/>
-                <a:cs typeface="Times New Roman" panose="02020603050405020304" pitchFamily="18" charset="0"/>
-              </a:rPr>
-              <a:t>：</a:t>
+              <a:t>使用了两种不同目标物质：</a:t>
             </a:r>
             <a:r>
               <a:rPr lang="en-US" altLang="zh-CN" sz="2000" dirty="0">
@@ -8121,7 +8105,7 @@
                 <a:ea typeface="宋体" panose="02010600030101010101" pitchFamily="2" charset="-122"/>
                 <a:cs typeface="Times New Roman" panose="02020603050405020304" pitchFamily="18" charset="0"/>
               </a:rPr>
-              <a:t> (TMP) : 18-20 psi </a:t>
+              <a:t> (TMP) : 18-20 psi  </a:t>
             </a:r>
             <a:r>
               <a:rPr lang="zh-CN" altLang="en-US" sz="2000" dirty="0">
@@ -8790,23 +8774,22 @@
           <a:lstStyle/>
           <a:p>
             <a:r>
-              <a:rPr lang="zh-CN" altLang="en-US" sz="2000">
+              <a:rPr lang="zh-CN" altLang="en-US" sz="2000" dirty="0">
                 <a:latin typeface="Times New Roman" panose="02020603050405020304" pitchFamily="18" charset="0"/>
                 <a:ea typeface="宋体" panose="02010600030101010101" pitchFamily="2" charset="-122"/>
                 <a:cs typeface="Times New Roman" panose="02020603050405020304" pitchFamily="18" charset="0"/>
               </a:rPr>
               <a:t>主要结果：杂质清除效率极高。</a:t>
             </a:r>
-            <a:r>
-              <a:rPr lang="en-US" altLang="zh-CN" sz="2000">
-                <a:latin typeface="Times New Roman" panose="02020603050405020304" pitchFamily="18" charset="0"/>
-                <a:ea typeface="宋体" panose="02010600030101010101" pitchFamily="2" charset="-122"/>
-                <a:cs typeface="Times New Roman" panose="02020603050405020304" pitchFamily="18" charset="0"/>
-              </a:rPr>
-              <a:t> </a:t>
-            </a:r>
-            <a:r>
-              <a:rPr lang="zh-CN" altLang="en-US" sz="2000">
+            <a:endParaRPr lang="en-US" altLang="zh-CN" sz="2000" dirty="0">
+              <a:latin typeface="Times New Roman" panose="02020603050405020304" pitchFamily="18" charset="0"/>
+              <a:ea typeface="宋体" panose="02010600030101010101" pitchFamily="2" charset="-122"/>
+              <a:cs typeface="Times New Roman" panose="02020603050405020304" pitchFamily="18" charset="0"/>
+            </a:endParaRPr>
+          </a:p>
+          <a:p>
+            <a:r>
+              <a:rPr lang="zh-CN" altLang="en-US" sz="2000" dirty="0">
                 <a:latin typeface="Times New Roman" panose="02020603050405020304" pitchFamily="18" charset="0"/>
                 <a:ea typeface="宋体" panose="02010600030101010101" pitchFamily="2" charset="-122"/>
                 <a:cs typeface="Times New Roman" panose="02020603050405020304" pitchFamily="18" charset="0"/>
@@ -8814,7 +8797,7 @@
               <a:t>实验结果显示，所有五种小分子杂质的浓度均随渗滤体积数的增加呈现出线性下降。计算得出的筛分系数（</a:t>
             </a:r>
             <a:r>
-              <a:rPr lang="en-US" altLang="zh-CN" sz="2000">
+              <a:rPr lang="en-US" altLang="zh-CN" sz="2000" dirty="0">
                 <a:latin typeface="Times New Roman" panose="02020603050405020304" pitchFamily="18" charset="0"/>
                 <a:ea typeface="宋体" panose="02010600030101010101" pitchFamily="2" charset="-122"/>
                 <a:cs typeface="Times New Roman" panose="02020603050405020304" pitchFamily="18" charset="0"/>
@@ -8822,7 +8805,7 @@
               <a:t>S</a:t>
             </a:r>
             <a:r>
-              <a:rPr lang="zh-CN" altLang="en-US" sz="2000">
+              <a:rPr lang="zh-CN" altLang="en-US" sz="2000" dirty="0">
                 <a:latin typeface="Times New Roman" panose="02020603050405020304" pitchFamily="18" charset="0"/>
                 <a:ea typeface="宋体" panose="02010600030101010101" pitchFamily="2" charset="-122"/>
                 <a:cs typeface="Times New Roman" panose="02020603050405020304" pitchFamily="18" charset="0"/>
@@ -8830,7 +8813,7 @@
               <a:t>）在</a:t>
             </a:r>
             <a:r>
-              <a:rPr lang="en-US" altLang="zh-CN" sz="2000">
+              <a:rPr lang="en-US" altLang="zh-CN" sz="2000" dirty="0">
                 <a:latin typeface="Times New Roman" panose="02020603050405020304" pitchFamily="18" charset="0"/>
                 <a:ea typeface="宋体" panose="02010600030101010101" pitchFamily="2" charset="-122"/>
                 <a:cs typeface="Times New Roman" panose="02020603050405020304" pitchFamily="18" charset="0"/>
@@ -8838,7 +8821,7 @@
               <a:t>0.85</a:t>
             </a:r>
             <a:r>
-              <a:rPr lang="zh-CN" altLang="en-US" sz="2000">
+              <a:rPr lang="zh-CN" altLang="en-US" sz="2000" dirty="0">
                 <a:latin typeface="Times New Roman" panose="02020603050405020304" pitchFamily="18" charset="0"/>
                 <a:ea typeface="宋体" panose="02010600030101010101" pitchFamily="2" charset="-122"/>
                 <a:cs typeface="Times New Roman" panose="02020603050405020304" pitchFamily="18" charset="0"/>
@@ -8846,7 +8829,7 @@
               <a:t>至</a:t>
             </a:r>
             <a:r>
-              <a:rPr lang="en-US" altLang="zh-CN" sz="2000">
+              <a:rPr lang="en-US" altLang="zh-CN" sz="2000" dirty="0">
                 <a:latin typeface="Times New Roman" panose="02020603050405020304" pitchFamily="18" charset="0"/>
                 <a:ea typeface="宋体" panose="02010600030101010101" pitchFamily="2" charset="-122"/>
                 <a:cs typeface="Times New Roman" panose="02020603050405020304" pitchFamily="18" charset="0"/>
@@ -8854,7 +8837,7 @@
               <a:t>0.99</a:t>
             </a:r>
             <a:r>
-              <a:rPr lang="zh-CN" altLang="en-US" sz="2000">
+              <a:rPr lang="zh-CN" altLang="en-US" sz="2000" dirty="0">
                 <a:latin typeface="Times New Roman" panose="02020603050405020304" pitchFamily="18" charset="0"/>
                 <a:ea typeface="宋体" panose="02010600030101010101" pitchFamily="2" charset="-122"/>
                 <a:cs typeface="Times New Roman" panose="02020603050405020304" pitchFamily="18" charset="0"/>
@@ -8862,7 +8845,7 @@
               <a:t>之间，非常接近理论最大值</a:t>
             </a:r>
             <a:r>
-              <a:rPr lang="en-US" altLang="zh-CN" sz="2000">
+              <a:rPr lang="en-US" altLang="zh-CN" sz="2000" dirty="0">
                 <a:latin typeface="Times New Roman" panose="02020603050405020304" pitchFamily="18" charset="0"/>
                 <a:ea typeface="宋体" panose="02010600030101010101" pitchFamily="2" charset="-122"/>
                 <a:cs typeface="Times New Roman" panose="02020603050405020304" pitchFamily="18" charset="0"/>
@@ -8870,7 +8853,7 @@
               <a:t>1</a:t>
             </a:r>
             <a:r>
-              <a:rPr lang="zh-CN" altLang="en-US" sz="2000">
+              <a:rPr lang="zh-CN" altLang="en-US" sz="2000" dirty="0">
                 <a:latin typeface="Times New Roman" panose="02020603050405020304" pitchFamily="18" charset="0"/>
                 <a:ea typeface="宋体" panose="02010600030101010101" pitchFamily="2" charset="-122"/>
                 <a:cs typeface="Times New Roman" panose="02020603050405020304" pitchFamily="18" charset="0"/>
@@ -8878,7 +8861,7 @@
               <a:t>。这表明，该</a:t>
             </a:r>
             <a:r>
-              <a:rPr lang="en-US" altLang="zh-CN" sz="2000">
+              <a:rPr lang="en-US" altLang="zh-CN" sz="2000" dirty="0">
                 <a:latin typeface="Times New Roman" panose="02020603050405020304" pitchFamily="18" charset="0"/>
                 <a:ea typeface="宋体" panose="02010600030101010101" pitchFamily="2" charset="-122"/>
                 <a:cs typeface="Times New Roman" panose="02020603050405020304" pitchFamily="18" charset="0"/>
@@ -8886,7 +8869,7 @@
               <a:t>TFF</a:t>
             </a:r>
             <a:r>
-              <a:rPr lang="zh-CN" altLang="en-US" sz="2000">
+              <a:rPr lang="zh-CN" altLang="en-US" sz="2000" dirty="0">
                 <a:latin typeface="Times New Roman" panose="02020603050405020304" pitchFamily="18" charset="0"/>
                 <a:ea typeface="宋体" panose="02010600030101010101" pitchFamily="2" charset="-122"/>
                 <a:cs typeface="Times New Roman" panose="02020603050405020304" pitchFamily="18" charset="0"/>
@@ -8894,7 +8877,7 @@
               <a:t>工艺能够以近乎理想的状态高效清除</a:t>
             </a:r>
             <a:r>
-              <a:rPr lang="en-US" altLang="zh-CN" sz="2000">
+              <a:rPr lang="en-US" altLang="zh-CN" sz="2000" dirty="0">
                 <a:latin typeface="Times New Roman" panose="02020603050405020304" pitchFamily="18" charset="0"/>
                 <a:ea typeface="宋体" panose="02010600030101010101" pitchFamily="2" charset="-122"/>
                 <a:cs typeface="Times New Roman" panose="02020603050405020304" pitchFamily="18" charset="0"/>
@@ -8902,7 +8885,7 @@
               <a:t>ADC</a:t>
             </a:r>
             <a:r>
-              <a:rPr lang="zh-CN" altLang="en-US" sz="2000">
+              <a:rPr lang="zh-CN" altLang="en-US" sz="2000" dirty="0">
                 <a:latin typeface="Times New Roman" panose="02020603050405020304" pitchFamily="18" charset="0"/>
                 <a:ea typeface="宋体" panose="02010600030101010101" pitchFamily="2" charset="-122"/>
                 <a:cs typeface="Times New Roman" panose="02020603050405020304" pitchFamily="18" charset="0"/>
@@ -8910,7 +8893,7 @@
               <a:t>工艺中常见的各类小分子杂质。例如，对于初始浓度约</a:t>
             </a:r>
             <a:r>
-              <a:rPr lang="en-US" altLang="zh-CN" sz="2000">
+              <a:rPr lang="en-US" altLang="zh-CN" sz="2000" dirty="0">
                 <a:latin typeface="Times New Roman" panose="02020603050405020304" pitchFamily="18" charset="0"/>
                 <a:ea typeface="宋体" panose="02010600030101010101" pitchFamily="2" charset="-122"/>
                 <a:cs typeface="Times New Roman" panose="02020603050405020304" pitchFamily="18" charset="0"/>
@@ -8918,7 +8901,7 @@
               <a:t>10%</a:t>
             </a:r>
             <a:r>
-              <a:rPr lang="zh-CN" altLang="en-US" sz="2000">
+              <a:rPr lang="zh-CN" altLang="en-US" sz="2000" dirty="0">
                 <a:latin typeface="Times New Roman" panose="02020603050405020304" pitchFamily="18" charset="0"/>
                 <a:ea typeface="宋体" panose="02010600030101010101" pitchFamily="2" charset="-122"/>
                 <a:cs typeface="Times New Roman" panose="02020603050405020304" pitchFamily="18" charset="0"/>
@@ -8926,7 +8909,7 @@
               <a:t>的</a:t>
             </a:r>
             <a:r>
-              <a:rPr lang="en-US" altLang="zh-CN" sz="2000">
+              <a:rPr lang="en-US" altLang="zh-CN" sz="2000" dirty="0">
                 <a:latin typeface="Times New Roman" panose="02020603050405020304" pitchFamily="18" charset="0"/>
                 <a:ea typeface="宋体" panose="02010600030101010101" pitchFamily="2" charset="-122"/>
                 <a:cs typeface="Times New Roman" panose="02020603050405020304" pitchFamily="18" charset="0"/>
@@ -8934,7 +8917,7 @@
               <a:t>DMA</a:t>
             </a:r>
             <a:r>
-              <a:rPr lang="zh-CN" altLang="en-US" sz="2000">
+              <a:rPr lang="zh-CN" altLang="en-US" sz="2000" dirty="0">
                 <a:latin typeface="Times New Roman" panose="02020603050405020304" pitchFamily="18" charset="0"/>
                 <a:ea typeface="宋体" panose="02010600030101010101" pitchFamily="2" charset="-122"/>
                 <a:cs typeface="Times New Roman" panose="02020603050405020304" pitchFamily="18" charset="0"/>
@@ -8942,7 +8925,7 @@
               <a:t>和</a:t>
             </a:r>
             <a:r>
-              <a:rPr lang="en-US" altLang="zh-CN" sz="2000">
+              <a:rPr lang="en-US" altLang="zh-CN" sz="2000" dirty="0">
                 <a:latin typeface="Times New Roman" panose="02020603050405020304" pitchFamily="18" charset="0"/>
                 <a:ea typeface="宋体" panose="02010600030101010101" pitchFamily="2" charset="-122"/>
                 <a:cs typeface="Times New Roman" panose="02020603050405020304" pitchFamily="18" charset="0"/>
@@ -8950,7 +8933,7 @@
               <a:t>DMSO</a:t>
             </a:r>
             <a:r>
-              <a:rPr lang="zh-CN" altLang="en-US" sz="2000">
+              <a:rPr lang="zh-CN" altLang="en-US" sz="2000" dirty="0">
                 <a:latin typeface="Times New Roman" panose="02020603050405020304" pitchFamily="18" charset="0"/>
                 <a:ea typeface="宋体" panose="02010600030101010101" pitchFamily="2" charset="-122"/>
                 <a:cs typeface="Times New Roman" panose="02020603050405020304" pitchFamily="18" charset="0"/>
@@ -8958,7 +8941,7 @@
               <a:t>，经过</a:t>
             </a:r>
             <a:r>
-              <a:rPr lang="en-US" altLang="zh-CN" sz="2000">
+              <a:rPr lang="en-US" altLang="zh-CN" sz="2000" dirty="0">
                 <a:latin typeface="Times New Roman" panose="02020603050405020304" pitchFamily="18" charset="0"/>
                 <a:ea typeface="宋体" panose="02010600030101010101" pitchFamily="2" charset="-122"/>
                 <a:cs typeface="Times New Roman" panose="02020603050405020304" pitchFamily="18" charset="0"/>
@@ -8966,7 +8949,7 @@
               <a:t>8</a:t>
             </a:r>
             <a:r>
-              <a:rPr lang="zh-CN" altLang="en-US" sz="2000">
+              <a:rPr lang="zh-CN" altLang="en-US" sz="2000" dirty="0">
                 <a:latin typeface="Times New Roman" panose="02020603050405020304" pitchFamily="18" charset="0"/>
                 <a:ea typeface="宋体" panose="02010600030101010101" pitchFamily="2" charset="-122"/>
                 <a:cs typeface="Times New Roman" panose="02020603050405020304" pitchFamily="18" charset="0"/>
@@ -8974,7 +8957,7 @@
               <a:t>个渗滤体积的操作后，其残留浓度降低了超过</a:t>
             </a:r>
             <a:r>
-              <a:rPr lang="en-US" altLang="zh-CN" sz="2000">
+              <a:rPr lang="en-US" altLang="zh-CN" sz="2000" dirty="0">
                 <a:latin typeface="Times New Roman" panose="02020603050405020304" pitchFamily="18" charset="0"/>
                 <a:ea typeface="宋体" panose="02010600030101010101" pitchFamily="2" charset="-122"/>
                 <a:cs typeface="Times New Roman" panose="02020603050405020304" pitchFamily="18" charset="0"/>
@@ -8982,7 +8965,7 @@
               <a:t>2000</a:t>
             </a:r>
             <a:r>
-              <a:rPr lang="zh-CN" altLang="en-US" sz="2000">
+              <a:rPr lang="zh-CN" altLang="en-US" sz="2000" dirty="0">
                 <a:latin typeface="Times New Roman" panose="02020603050405020304" pitchFamily="18" charset="0"/>
                 <a:ea typeface="宋体" panose="02010600030101010101" pitchFamily="2" charset="-122"/>
                 <a:cs typeface="Times New Roman" panose="02020603050405020304" pitchFamily="18" charset="0"/>

</xml_diff>